<commit_message>
Suma al deck el enfoque, el roadmap y la arquitectura
Dos laminas de cierre para responder el "y como lo hacemos":

- Nuestro enfoque: cuatro principios (identidad primero, orquestar en
  vez de migrar, reglas centralizadas, entregar por valor) y un roadmap
  de cuatro fases con plazos estimados.
- Como se construye: la app como capa de orquestacion sobre los
  sistemas actuales, con servicios, conectores y principios tecnicos.

Deja explicito que Bonus es un programa de consorcio con Cencosud y
Delosi, asi que se integra y no se absorbe.

Ignora los temporales ~$ de Office.

Co-Authored-By: Claude Opus 5 <noreply@anthropic.com>
</commit_message>
<xml_diff>
--- a/Primax-ID-5-casos-de-uso.pptx
+++ b/Primax-ID-5-casos-de-uso.pptx
@@ -10,9 +10,11 @@
     <p:sldId id="258" r:id="rId4"/>
     <p:sldId id="259" r:id="rId5"/>
     <p:sldId id="260" r:id="rId6"/>
+    <p:sldId id="261" r:id="rId7"/>
+    <p:sldId id="262" r:id="rId8"/>
   </p:sldIdLst>
   <p:notesMasterIdLst>
-    <p:notesMasterId r:id="rId7"/>
+    <p:notesMasterId r:id="rId9"/>
   </p:notesMasterIdLst>
   <p:sldSz cx="12192000" cy="6858000"/>
   <p:notesSz cx="6858000" cy="12192000"/>
@@ -882,6 +884,182 @@
             <a:fld id="{F7021451-1387-4CA6-816F-3879F97B5CBC}" type="slidenum">
               <a:rPr lang="en-US"/>
               <a:t>5</a:t>
+            </a:fld>
+            <a:endParaRPr lang="en-US"/>
+          </a:p>
+        </p:txBody>
+      </p:sp>
+    </p:spTree>
+    <p:extLst>
+      <p:ext uri="{BB962C8B-B14F-4D97-AF65-F5344CB8AC3E}">
+        <p14:creationId xmlns:p14="http://schemas.microsoft.com/office/powerpoint/2010/main" val="1024086991"/>
+      </p:ext>
+    </p:extLst>
+  </p:cSld>
+  <p:clrMapOvr>
+    <a:masterClrMapping/>
+  </p:clrMapOvr>
+</p:notes>
+</file>
+
+<file path=ppt/notesSlides/notesSlide6.xml><?xml version="1.0" encoding="utf-8"?>
+<p:notes xmlns:a="http://schemas.openxmlformats.org/drawingml/2006/main" xmlns:r="http://schemas.openxmlformats.org/officeDocument/2006/relationships" xmlns:p="http://schemas.openxmlformats.org/presentationml/2006/main">
+  <p:cSld>
+    <p:spTree>
+      <p:nvGrpSpPr>
+        <p:cNvPr id="1" name=""/>
+        <p:cNvGrpSpPr/>
+        <p:nvPr/>
+      </p:nvGrpSpPr>
+      <p:grpSpPr>
+        <a:xfrm>
+          <a:off x="0" y="0"/>
+          <a:ext cx="0" cy="0"/>
+          <a:chOff x="0" y="0"/>
+          <a:chExt cx="0" cy="0"/>
+        </a:xfrm>
+      </p:grpSpPr>
+      <p:sp>
+        <p:nvSpPr>
+          <p:cNvPr id="2" name="Slide Image Placeholder 1"/>
+          <p:cNvSpPr>
+            <a:spLocks noGrp="1" noRot="1" noChangeAspect="1"/>
+          </p:cNvSpPr>
+          <p:nvPr>
+            <p:ph type="sldImg"/>
+          </p:nvPr>
+        </p:nvSpPr>
+        <p:spPr/>
+      </p:sp>
+      <p:sp>
+        <p:nvSpPr>
+          <p:cNvPr id="3" name="Notes Placeholder 2"/>
+          <p:cNvSpPr>
+            <a:spLocks noGrp="1"/>
+          </p:cNvSpPr>
+          <p:nvPr>
+            <p:ph type="body" idx="1"/>
+          </p:nvPr>
+        </p:nvSpPr>
+        <p:spPr/>
+        <p:txBody>
+          <a:bodyPr/>
+          <a:lstStyle/>
+          <a:p>
+            <a:r>
+              <a:rPr lang="en-US" dirty="0"/>
+              <a:t>Si preguntan por el orden: la identidad va primero porque sin ID único no hay nada que unificar. El pago va segundo porque es donde está el ahorro visible, pero necesita integración con POS y por eso no puede ser lo primero.</a:t>
+            </a:r>
+            <a:endParaRPr lang="en-US" dirty="0"/>
+          </a:p>
+        </p:txBody>
+      </p:sp>
+      <p:sp>
+        <p:nvSpPr>
+          <p:cNvPr id="4" name="Slide Number Placeholder 3"/>
+          <p:cNvSpPr>
+            <a:spLocks noGrp="1"/>
+          </p:cNvSpPr>
+          <p:nvPr>
+            <p:ph type="sldNum" sz="quarter" idx="10"/>
+          </p:nvPr>
+        </p:nvSpPr>
+        <p:spPr/>
+        <p:txBody>
+          <a:bodyPr/>
+          <a:lstStyle/>
+          <a:p>
+            <a:fld id="{F7021451-1387-4CA6-816F-3879F97B5CBC}" type="slidenum">
+              <a:rPr lang="en-US"/>
+              <a:t>6</a:t>
+            </a:fld>
+            <a:endParaRPr lang="en-US"/>
+          </a:p>
+        </p:txBody>
+      </p:sp>
+    </p:spTree>
+    <p:extLst>
+      <p:ext uri="{BB962C8B-B14F-4D97-AF65-F5344CB8AC3E}">
+        <p14:creationId xmlns:p14="http://schemas.microsoft.com/office/powerpoint/2010/main" val="1024086991"/>
+      </p:ext>
+    </p:extLst>
+  </p:cSld>
+  <p:clrMapOvr>
+    <a:masterClrMapping/>
+  </p:clrMapOvr>
+</p:notes>
+</file>
+
+<file path=ppt/notesSlides/notesSlide7.xml><?xml version="1.0" encoding="utf-8"?>
+<p:notes xmlns:a="http://schemas.openxmlformats.org/drawingml/2006/main" xmlns:r="http://schemas.openxmlformats.org/officeDocument/2006/relationships" xmlns:p="http://schemas.openxmlformats.org/presentationml/2006/main">
+  <p:cSld>
+    <p:spTree>
+      <p:nvGrpSpPr>
+        <p:cNvPr id="1" name=""/>
+        <p:cNvGrpSpPr/>
+        <p:nvPr/>
+      </p:nvGrpSpPr>
+      <p:grpSpPr>
+        <a:xfrm>
+          <a:off x="0" y="0"/>
+          <a:ext cx="0" cy="0"/>
+          <a:chOff x="0" y="0"/>
+          <a:chExt cx="0" cy="0"/>
+        </a:xfrm>
+      </p:grpSpPr>
+      <p:sp>
+        <p:nvSpPr>
+          <p:cNvPr id="2" name="Slide Image Placeholder 1"/>
+          <p:cNvSpPr>
+            <a:spLocks noGrp="1" noRot="1" noChangeAspect="1"/>
+          </p:cNvSpPr>
+          <p:nvPr>
+            <p:ph type="sldImg"/>
+          </p:nvPr>
+        </p:nvSpPr>
+        <p:spPr/>
+      </p:sp>
+      <p:sp>
+        <p:nvSpPr>
+          <p:cNvPr id="3" name="Notes Placeholder 2"/>
+          <p:cNvSpPr>
+            <a:spLocks noGrp="1"/>
+          </p:cNvSpPr>
+          <p:nvPr>
+            <p:ph type="body" idx="1"/>
+          </p:nvPr>
+        </p:nvSpPr>
+        <p:spPr/>
+        <p:txBody>
+          <a:bodyPr/>
+          <a:lstStyle/>
+          <a:p>
+            <a:r>
+              <a:rPr lang="en-US" dirty="0"/>
+              <a:t>El punto de esta lámina es bajar el riesgo percibido: no se toca lo que hoy funciona. Si preguntan por el esfuerzo de integración, la respuesta está en la Fase 0 del roadmap.</a:t>
+            </a:r>
+            <a:endParaRPr lang="en-US" dirty="0"/>
+          </a:p>
+        </p:txBody>
+      </p:sp>
+      <p:sp>
+        <p:nvSpPr>
+          <p:cNvPr id="4" name="Slide Number Placeholder 3"/>
+          <p:cNvSpPr>
+            <a:spLocks noGrp="1"/>
+          </p:cNvSpPr>
+          <p:nvPr>
+            <p:ph type="sldNum" sz="quarter" idx="10"/>
+          </p:nvPr>
+        </p:nvSpPr>
+        <p:spPr/>
+        <p:txBody>
+          <a:bodyPr/>
+          <a:lstStyle/>
+          <a:p>
+            <a:fld id="{F7021451-1387-4CA6-816F-3879F97B5CBC}" type="slidenum">
+              <a:rPr lang="en-US"/>
+              <a:t>7</a:t>
             </a:fld>
             <a:endParaRPr lang="en-US"/>
           </a:p>
@@ -6339,6 +6517,3137 @@
 </p:sld>
 </file>
 
+<file path=ppt/slides/slide6.xml><?xml version="1.0" encoding="utf-8"?>
+<p:sld xmlns:a="http://schemas.openxmlformats.org/drawingml/2006/main" xmlns:r="http://schemas.openxmlformats.org/officeDocument/2006/relationships" xmlns:p="http://schemas.openxmlformats.org/presentationml/2006/main">
+  <p:cSld name="Slide 6">
+    <p:bg>
+      <p:bgPr>
+        <a:blipFill dpi="0" rotWithShape="1">
+          <a:blip r:embed="rId1">
+            <a:lum/>
+          </a:blip>
+          <a:srcRect/>
+          <a:stretch>
+            <a:fillRect/>
+          </a:stretch>
+        </a:blipFill>
+        <a:effectLst/>
+      </p:bgPr>
+    </p:bg>
+    <p:spTree>
+      <p:nvGrpSpPr>
+        <p:cNvPr id="1" name=""/>
+        <p:cNvGrpSpPr/>
+        <p:nvPr/>
+      </p:nvGrpSpPr>
+      <p:grpSpPr>
+        <a:xfrm>
+          <a:off x="0" y="0"/>
+          <a:ext cx="0" cy="0"/>
+          <a:chOff x="0" y="0"/>
+          <a:chExt cx="0" cy="0"/>
+        </a:xfrm>
+      </p:grpSpPr>
+      <p:sp>
+        <p:nvSpPr>
+          <p:cNvPr id="2" name="Text 0"/>
+          <p:cNvSpPr/>
+          <p:nvPr/>
+        </p:nvSpPr>
+        <p:spPr>
+          <a:xfrm>
+            <a:off x="640080" y="457200"/>
+            <a:ext cx="5486400" cy="274320"/>
+          </a:xfrm>
+          <a:prstGeom prst="rect">
+            <a:avLst/>
+          </a:prstGeom>
+          <a:noFill/>
+          <a:ln/>
+        </p:spPr>
+        <p:txBody>
+          <a:bodyPr wrap="square" lIns="0" tIns="0" rIns="0" bIns="0" rtlCol="0" anchor="ctr"/>
+          <a:lstStyle/>
+          <a:p>
+            <a:pPr indent="0" marL="0">
+              <a:buNone/>
+            </a:pPr>
+            <a:r>
+              <a:rPr lang="en-US" sz="1150" b="1" spc="240" kern="0" dirty="0">
+                <a:solidFill>
+                  <a:srgbClr val="FBA919"/>
+                </a:solidFill>
+                <a:latin typeface="Calibri" pitchFamily="34" charset="0"/>
+                <a:ea typeface="Calibri" pitchFamily="34" charset="-122"/>
+                <a:cs typeface="Calibri" pitchFamily="34" charset="-120"/>
+              </a:rPr>
+              <a:t>NUESTRO ENFOQUE</a:t>
+            </a:r>
+            <a:endParaRPr lang="en-US" sz="1150" dirty="0"/>
+          </a:p>
+        </p:txBody>
+      </p:sp>
+      <p:sp>
+        <p:nvSpPr>
+          <p:cNvPr id="3" name="Text 1"/>
+          <p:cNvSpPr/>
+          <p:nvPr/>
+        </p:nvSpPr>
+        <p:spPr>
+          <a:xfrm>
+            <a:off x="640080" y="777240"/>
+            <a:ext cx="9326880" cy="914400"/>
+          </a:xfrm>
+          <a:prstGeom prst="rect">
+            <a:avLst/>
+          </a:prstGeom>
+          <a:noFill/>
+          <a:ln/>
+        </p:spPr>
+        <p:txBody>
+          <a:bodyPr wrap="square" lIns="0" tIns="0" rIns="0" bIns="0" rtlCol="0" anchor="t"/>
+          <a:lstStyle/>
+          <a:p>
+            <a:pPr indent="0" marL="0">
+              <a:lnSpc>
+                <a:spcPts val="3800"/>
+              </a:lnSpc>
+              <a:buNone/>
+            </a:pPr>
+            <a:r>
+              <a:rPr lang="en-US" sz="3300" b="1" dirty="0">
+                <a:solidFill>
+                  <a:srgbClr val="FFFFFF"/>
+                </a:solidFill>
+                <a:latin typeface="Calibri" pitchFamily="34" charset="0"/>
+                <a:ea typeface="Calibri" pitchFamily="34" charset="-122"/>
+                <a:cs typeface="Calibri" pitchFamily="34" charset="-120"/>
+              </a:rPr>
+              <a:t>Cómo lo llevamos de la demo a producción</a:t>
+            </a:r>
+            <a:endParaRPr lang="en-US" sz="3300" dirty="0"/>
+          </a:p>
+        </p:txBody>
+      </p:sp>
+      <p:sp>
+        <p:nvSpPr>
+          <p:cNvPr id="4" name="Text 2"/>
+          <p:cNvSpPr/>
+          <p:nvPr/>
+        </p:nvSpPr>
+        <p:spPr>
+          <a:xfrm>
+            <a:off x="640080" y="1709928"/>
+            <a:ext cx="9692640" cy="310896"/>
+          </a:xfrm>
+          <a:prstGeom prst="rect">
+            <a:avLst/>
+          </a:prstGeom>
+          <a:noFill/>
+          <a:ln/>
+        </p:spPr>
+        <p:txBody>
+          <a:bodyPr wrap="square" lIns="0" tIns="0" rIns="0" bIns="0" rtlCol="0" anchor="ctr"/>
+          <a:lstStyle/>
+          <a:p>
+            <a:pPr indent="0" marL="0">
+              <a:buNone/>
+            </a:pPr>
+            <a:r>
+              <a:rPr lang="en-US" sz="1350" dirty="0">
+                <a:solidFill>
+                  <a:srgbClr val="A9B2DC"/>
+                </a:solidFill>
+                <a:latin typeface="Calibri" pitchFamily="34" charset="0"/>
+                <a:ea typeface="Calibri" pitchFamily="34" charset="-122"/>
+                <a:cs typeface="Calibri" pitchFamily="34" charset="-120"/>
+              </a:rPr>
+              <a:t>En capas: primero la identidad, después el pago, el engagement encima. Sin big bang y sin frenar la operación actual.</a:t>
+            </a:r>
+            <a:endParaRPr lang="en-US" sz="1350" dirty="0"/>
+          </a:p>
+        </p:txBody>
+      </p:sp>
+      <p:sp>
+        <p:nvSpPr>
+          <p:cNvPr id="5" name="Shape 3"/>
+          <p:cNvSpPr/>
+          <p:nvPr/>
+        </p:nvSpPr>
+        <p:spPr>
+          <a:xfrm>
+            <a:off x="10515600" y="457200"/>
+            <a:ext cx="1325880" cy="658368"/>
+          </a:xfrm>
+          <a:prstGeom prst="roundRect">
+            <a:avLst>
+              <a:gd name="adj" fmla="val 13889"/>
+            </a:avLst>
+          </a:prstGeom>
+          <a:solidFill>
+            <a:srgbClr val="FFFFFF"/>
+          </a:solidFill>
+          <a:ln/>
+        </p:spPr>
+      </p:sp>
+      <p:pic>
+        <p:nvPicPr>
+          <p:cNvPr id="6" name="Image 0" descr="C:/Users/Axel/Documents/Axel/Repos Claude/cx-demo-app/public/logo-wordmark.jpg">    </p:cNvPr>
+          <p:cNvPicPr>
+            <a:picLocks noChangeAspect="1"/>
+          </p:cNvPicPr>
+          <p:nvPr/>
+        </p:nvPicPr>
+        <p:blipFill>
+          <a:blip r:embed="rId2"/>
+          <a:stretch>
+            <a:fillRect/>
+          </a:stretch>
+        </p:blipFill>
+        <p:spPr>
+          <a:xfrm>
+            <a:off x="10616184" y="576072"/>
+            <a:ext cx="1124712" cy="420624"/>
+          </a:xfrm>
+          <a:prstGeom prst="rect">
+            <a:avLst/>
+          </a:prstGeom>
+        </p:spPr>
+      </p:pic>
+      <p:sp>
+        <p:nvSpPr>
+          <p:cNvPr id="7" name="Shape 4"/>
+          <p:cNvSpPr/>
+          <p:nvPr/>
+        </p:nvSpPr>
+        <p:spPr>
+          <a:xfrm>
+            <a:off x="640080" y="2148840"/>
+            <a:ext cx="3977640" cy="3721608"/>
+          </a:xfrm>
+          <a:prstGeom prst="roundRect">
+            <a:avLst>
+              <a:gd name="adj" fmla="val 3440"/>
+            </a:avLst>
+          </a:prstGeom>
+          <a:solidFill>
+            <a:srgbClr val="18215C"/>
+          </a:solidFill>
+          <a:ln w="7620">
+            <a:solidFill>
+              <a:srgbClr val="FFFFFF">
+                <a:alpha val="12000"/>
+              </a:srgbClr>
+            </a:solidFill>
+            <a:prstDash val="solid"/>
+          </a:ln>
+          <a:effectLst>
+            <a:outerShdw sx="100000" sy="100000" kx="0" ky="0" algn="bl" rotWithShape="0" blurRad="177800" dist="50800" dir="5400000">
+              <a:srgbClr val="000000">
+                <a:alpha val="30000"/>
+              </a:srgbClr>
+            </a:outerShdw>
+          </a:effectLst>
+        </p:spPr>
+      </p:sp>
+      <p:sp>
+        <p:nvSpPr>
+          <p:cNvPr id="8" name="Shape 5"/>
+          <p:cNvSpPr/>
+          <p:nvPr/>
+        </p:nvSpPr>
+        <p:spPr>
+          <a:xfrm>
+            <a:off x="960120" y="2395728"/>
+            <a:ext cx="402336" cy="402336"/>
+          </a:xfrm>
+          <a:prstGeom prst="ellipse">
+            <a:avLst/>
+          </a:prstGeom>
+          <a:solidFill>
+            <a:srgbClr val="F4610C"/>
+          </a:solidFill>
+          <a:ln w="12700">
+            <a:solidFill>
+              <a:srgbClr val="F4610C"/>
+            </a:solidFill>
+            <a:prstDash val="solid"/>
+          </a:ln>
+        </p:spPr>
+      </p:sp>
+      <p:pic>
+        <p:nvPicPr>
+          <p:cNvPr id="9" name="Image 1" descr="preencoded.png">    </p:cNvPr>
+          <p:cNvPicPr>
+            <a:picLocks noChangeAspect="1"/>
+          </p:cNvPicPr>
+          <p:nvPr/>
+        </p:nvPicPr>
+        <p:blipFill>
+          <a:blip r:embed="rId3"/>
+          <a:stretch>
+            <a:fillRect/>
+          </a:stretch>
+        </p:blipFill>
+        <p:spPr>
+          <a:xfrm>
+            <a:off x="1054669" y="2490277"/>
+            <a:ext cx="213238" cy="213238"/>
+          </a:xfrm>
+          <a:prstGeom prst="rect">
+            <a:avLst/>
+          </a:prstGeom>
+        </p:spPr>
+      </p:pic>
+      <p:sp>
+        <p:nvSpPr>
+          <p:cNvPr id="10" name="Text 6"/>
+          <p:cNvSpPr/>
+          <p:nvPr/>
+        </p:nvSpPr>
+        <p:spPr>
+          <a:xfrm>
+            <a:off x="1481328" y="2432304"/>
+            <a:ext cx="2834640" cy="274320"/>
+          </a:xfrm>
+          <a:prstGeom prst="rect">
+            <a:avLst/>
+          </a:prstGeom>
+          <a:noFill/>
+          <a:ln/>
+        </p:spPr>
+        <p:txBody>
+          <a:bodyPr wrap="square" lIns="0" tIns="0" rIns="0" bIns="0" rtlCol="0" anchor="ctr"/>
+          <a:lstStyle/>
+          <a:p>
+            <a:pPr indent="0" marL="0">
+              <a:buNone/>
+            </a:pPr>
+            <a:r>
+              <a:rPr lang="en-US" sz="1350" b="1" dirty="0">
+                <a:solidFill>
+                  <a:srgbClr val="FFFFFF"/>
+                </a:solidFill>
+                <a:latin typeface="Calibri" pitchFamily="34" charset="0"/>
+                <a:ea typeface="Calibri" pitchFamily="34" charset="-122"/>
+                <a:cs typeface="Calibri" pitchFamily="34" charset="-120"/>
+              </a:rPr>
+              <a:t>La identidad primero</a:t>
+            </a:r>
+            <a:endParaRPr lang="en-US" sz="1350" dirty="0"/>
+          </a:p>
+        </p:txBody>
+      </p:sp>
+      <p:sp>
+        <p:nvSpPr>
+          <p:cNvPr id="11" name="Text 7"/>
+          <p:cNvSpPr/>
+          <p:nvPr/>
+        </p:nvSpPr>
+        <p:spPr>
+          <a:xfrm>
+            <a:off x="960120" y="2816352"/>
+            <a:ext cx="3355848" cy="438912"/>
+          </a:xfrm>
+          <a:prstGeom prst="rect">
+            <a:avLst/>
+          </a:prstGeom>
+          <a:noFill/>
+          <a:ln/>
+        </p:spPr>
+        <p:txBody>
+          <a:bodyPr wrap="square" lIns="0" tIns="0" rIns="0" bIns="0" rtlCol="0" anchor="ctr"/>
+          <a:lstStyle/>
+          <a:p>
+            <a:pPr indent="0" marL="0">
+              <a:lnSpc>
+                <a:spcPts val="1500"/>
+              </a:lnSpc>
+              <a:buNone/>
+            </a:pPr>
+            <a:r>
+              <a:rPr lang="en-US" sz="1100" dirty="0">
+                <a:solidFill>
+                  <a:srgbClr val="A9B2DC"/>
+                </a:solidFill>
+                <a:latin typeface="Calibri" pitchFamily="34" charset="0"/>
+                <a:ea typeface="Calibri" pitchFamily="34" charset="-122"/>
+                <a:cs typeface="Calibri" pitchFamily="34" charset="-120"/>
+              </a:rPr>
+              <a:t>Sin un ID único de cliente no hay nada que unificar.</a:t>
+            </a:r>
+            <a:endParaRPr lang="en-US" sz="1100" dirty="0"/>
+          </a:p>
+        </p:txBody>
+      </p:sp>
+      <p:sp>
+        <p:nvSpPr>
+          <p:cNvPr id="12" name="Shape 8"/>
+          <p:cNvSpPr/>
+          <p:nvPr/>
+        </p:nvSpPr>
+        <p:spPr>
+          <a:xfrm>
+            <a:off x="960120" y="3282696"/>
+            <a:ext cx="402336" cy="402336"/>
+          </a:xfrm>
+          <a:prstGeom prst="ellipse">
+            <a:avLst/>
+          </a:prstGeom>
+          <a:solidFill>
+            <a:srgbClr val="F4610C"/>
+          </a:solidFill>
+          <a:ln w="12700">
+            <a:solidFill>
+              <a:srgbClr val="F4610C"/>
+            </a:solidFill>
+            <a:prstDash val="solid"/>
+          </a:ln>
+        </p:spPr>
+      </p:sp>
+      <p:pic>
+        <p:nvPicPr>
+          <p:cNvPr id="13" name="Image 2" descr="preencoded.png">    </p:cNvPr>
+          <p:cNvPicPr>
+            <a:picLocks noChangeAspect="1"/>
+          </p:cNvPicPr>
+          <p:nvPr/>
+        </p:nvPicPr>
+        <p:blipFill>
+          <a:blip r:embed="rId4"/>
+          <a:stretch>
+            <a:fillRect/>
+          </a:stretch>
+        </p:blipFill>
+        <p:spPr>
+          <a:xfrm>
+            <a:off x="1054669" y="3377245"/>
+            <a:ext cx="213238" cy="213238"/>
+          </a:xfrm>
+          <a:prstGeom prst="rect">
+            <a:avLst/>
+          </a:prstGeom>
+        </p:spPr>
+      </p:pic>
+      <p:sp>
+        <p:nvSpPr>
+          <p:cNvPr id="14" name="Text 9"/>
+          <p:cNvSpPr/>
+          <p:nvPr/>
+        </p:nvSpPr>
+        <p:spPr>
+          <a:xfrm>
+            <a:off x="1481328" y="3319272"/>
+            <a:ext cx="2834640" cy="274320"/>
+          </a:xfrm>
+          <a:prstGeom prst="rect">
+            <a:avLst/>
+          </a:prstGeom>
+          <a:noFill/>
+          <a:ln/>
+        </p:spPr>
+        <p:txBody>
+          <a:bodyPr wrap="square" lIns="0" tIns="0" rIns="0" bIns="0" rtlCol="0" anchor="ctr"/>
+          <a:lstStyle/>
+          <a:p>
+            <a:pPr indent="0" marL="0">
+              <a:buNone/>
+            </a:pPr>
+            <a:r>
+              <a:rPr lang="en-US" sz="1350" b="1" dirty="0">
+                <a:solidFill>
+                  <a:srgbClr val="FFFFFF"/>
+                </a:solidFill>
+                <a:latin typeface="Calibri" pitchFamily="34" charset="0"/>
+                <a:ea typeface="Calibri" pitchFamily="34" charset="-122"/>
+                <a:cs typeface="Calibri" pitchFamily="34" charset="-120"/>
+              </a:rPr>
+              <a:t>Orquestar, no migrar</a:t>
+            </a:r>
+            <a:endParaRPr lang="en-US" sz="1350" dirty="0"/>
+          </a:p>
+        </p:txBody>
+      </p:sp>
+      <p:sp>
+        <p:nvSpPr>
+          <p:cNvPr id="15" name="Text 10"/>
+          <p:cNvSpPr/>
+          <p:nvPr/>
+        </p:nvSpPr>
+        <p:spPr>
+          <a:xfrm>
+            <a:off x="960120" y="3703320"/>
+            <a:ext cx="3355848" cy="438912"/>
+          </a:xfrm>
+          <a:prstGeom prst="rect">
+            <a:avLst/>
+          </a:prstGeom>
+          <a:noFill/>
+          <a:ln/>
+        </p:spPr>
+        <p:txBody>
+          <a:bodyPr wrap="square" lIns="0" tIns="0" rIns="0" bIns="0" rtlCol="0" anchor="ctr"/>
+          <a:lstStyle/>
+          <a:p>
+            <a:pPr indent="0" marL="0">
+              <a:lnSpc>
+                <a:spcPts val="1500"/>
+              </a:lnSpc>
+              <a:buNone/>
+            </a:pPr>
+            <a:r>
+              <a:rPr lang="en-US" sz="1100" dirty="0">
+                <a:solidFill>
+                  <a:srgbClr val="A9B2DC"/>
+                </a:solidFill>
+                <a:latin typeface="Calibri" pitchFamily="34" charset="0"/>
+                <a:ea typeface="Calibri" pitchFamily="34" charset="-122"/>
+                <a:cs typeface="Calibri" pitchFamily="34" charset="-120"/>
+              </a:rPr>
+              <a:t>Cada programa sigue en su sistema; la app los coordina.</a:t>
+            </a:r>
+            <a:endParaRPr lang="en-US" sz="1100" dirty="0"/>
+          </a:p>
+        </p:txBody>
+      </p:sp>
+      <p:sp>
+        <p:nvSpPr>
+          <p:cNvPr id="16" name="Shape 11"/>
+          <p:cNvSpPr/>
+          <p:nvPr/>
+        </p:nvSpPr>
+        <p:spPr>
+          <a:xfrm>
+            <a:off x="960120" y="4169664"/>
+            <a:ext cx="402336" cy="402336"/>
+          </a:xfrm>
+          <a:prstGeom prst="ellipse">
+            <a:avLst/>
+          </a:prstGeom>
+          <a:solidFill>
+            <a:srgbClr val="F4610C"/>
+          </a:solidFill>
+          <a:ln w="12700">
+            <a:solidFill>
+              <a:srgbClr val="F4610C"/>
+            </a:solidFill>
+            <a:prstDash val="solid"/>
+          </a:ln>
+        </p:spPr>
+      </p:sp>
+      <p:pic>
+        <p:nvPicPr>
+          <p:cNvPr id="17" name="Image 3" descr="preencoded.png">    </p:cNvPr>
+          <p:cNvPicPr>
+            <a:picLocks noChangeAspect="1"/>
+          </p:cNvPicPr>
+          <p:nvPr/>
+        </p:nvPicPr>
+        <p:blipFill>
+          <a:blip r:embed="rId5"/>
+          <a:stretch>
+            <a:fillRect/>
+          </a:stretch>
+        </p:blipFill>
+        <p:spPr>
+          <a:xfrm>
+            <a:off x="1054669" y="4264213"/>
+            <a:ext cx="213238" cy="213238"/>
+          </a:xfrm>
+          <a:prstGeom prst="rect">
+            <a:avLst/>
+          </a:prstGeom>
+        </p:spPr>
+      </p:pic>
+      <p:sp>
+        <p:nvSpPr>
+          <p:cNvPr id="18" name="Text 12"/>
+          <p:cNvSpPr/>
+          <p:nvPr/>
+        </p:nvSpPr>
+        <p:spPr>
+          <a:xfrm>
+            <a:off x="1481328" y="4206240"/>
+            <a:ext cx="2834640" cy="274320"/>
+          </a:xfrm>
+          <a:prstGeom prst="rect">
+            <a:avLst/>
+          </a:prstGeom>
+          <a:noFill/>
+          <a:ln/>
+        </p:spPr>
+        <p:txBody>
+          <a:bodyPr wrap="square" lIns="0" tIns="0" rIns="0" bIns="0" rtlCol="0" anchor="ctr"/>
+          <a:lstStyle/>
+          <a:p>
+            <a:pPr indent="0" marL="0">
+              <a:buNone/>
+            </a:pPr>
+            <a:r>
+              <a:rPr lang="en-US" sz="1350" b="1" dirty="0">
+                <a:solidFill>
+                  <a:srgbClr val="FFFFFF"/>
+                </a:solidFill>
+                <a:latin typeface="Calibri" pitchFamily="34" charset="0"/>
+                <a:ea typeface="Calibri" pitchFamily="34" charset="-122"/>
+                <a:cs typeface="Calibri" pitchFamily="34" charset="-120"/>
+              </a:rPr>
+              <a:t>Las reglas, en un solo lugar</a:t>
+            </a:r>
+            <a:endParaRPr lang="en-US" sz="1350" dirty="0"/>
+          </a:p>
+        </p:txBody>
+      </p:sp>
+      <p:sp>
+        <p:nvSpPr>
+          <p:cNvPr id="19" name="Text 13"/>
+          <p:cNvSpPr/>
+          <p:nvPr/>
+        </p:nvSpPr>
+        <p:spPr>
+          <a:xfrm>
+            <a:off x="960120" y="4590288"/>
+            <a:ext cx="3355848" cy="438912"/>
+          </a:xfrm>
+          <a:prstGeom prst="rect">
+            <a:avLst/>
+          </a:prstGeom>
+          <a:noFill/>
+          <a:ln/>
+        </p:spPr>
+        <p:txBody>
+          <a:bodyPr wrap="square" lIns="0" tIns="0" rIns="0" bIns="0" rtlCol="0" anchor="ctr"/>
+          <a:lstStyle/>
+          <a:p>
+            <a:pPr indent="0" marL="0">
+              <a:lnSpc>
+                <a:spcPts val="1500"/>
+              </a:lnSpc>
+              <a:buNone/>
+            </a:pPr>
+            <a:r>
+              <a:rPr lang="en-US" sz="1100" dirty="0">
+                <a:solidFill>
+                  <a:srgbClr val="A9B2DC"/>
+                </a:solidFill>
+                <a:latin typeface="Calibri" pitchFamily="34" charset="0"/>
+                <a:ea typeface="Calibri" pitchFamily="34" charset="-122"/>
+                <a:cs typeface="Calibri" pitchFamily="34" charset="-120"/>
+              </a:rPr>
+              <a:t>Un motor central y versionado, no reglas repartidas.</a:t>
+            </a:r>
+            <a:endParaRPr lang="en-US" sz="1100" dirty="0"/>
+          </a:p>
+        </p:txBody>
+      </p:sp>
+      <p:sp>
+        <p:nvSpPr>
+          <p:cNvPr id="20" name="Shape 14"/>
+          <p:cNvSpPr/>
+          <p:nvPr/>
+        </p:nvSpPr>
+        <p:spPr>
+          <a:xfrm>
+            <a:off x="960120" y="5056632"/>
+            <a:ext cx="402336" cy="402336"/>
+          </a:xfrm>
+          <a:prstGeom prst="ellipse">
+            <a:avLst/>
+          </a:prstGeom>
+          <a:solidFill>
+            <a:srgbClr val="F4610C"/>
+          </a:solidFill>
+          <a:ln w="12700">
+            <a:solidFill>
+              <a:srgbClr val="F4610C"/>
+            </a:solidFill>
+            <a:prstDash val="solid"/>
+          </a:ln>
+        </p:spPr>
+      </p:sp>
+      <p:pic>
+        <p:nvPicPr>
+          <p:cNvPr id="21" name="Image 4" descr="preencoded.png">    </p:cNvPr>
+          <p:cNvPicPr>
+            <a:picLocks noChangeAspect="1"/>
+          </p:cNvPicPr>
+          <p:nvPr/>
+        </p:nvPicPr>
+        <p:blipFill>
+          <a:blip r:embed="rId6"/>
+          <a:stretch>
+            <a:fillRect/>
+          </a:stretch>
+        </p:blipFill>
+        <p:spPr>
+          <a:xfrm>
+            <a:off x="1054669" y="5151181"/>
+            <a:ext cx="213238" cy="213238"/>
+          </a:xfrm>
+          <a:prstGeom prst="rect">
+            <a:avLst/>
+          </a:prstGeom>
+        </p:spPr>
+      </p:pic>
+      <p:sp>
+        <p:nvSpPr>
+          <p:cNvPr id="22" name="Text 15"/>
+          <p:cNvSpPr/>
+          <p:nvPr/>
+        </p:nvSpPr>
+        <p:spPr>
+          <a:xfrm>
+            <a:off x="1481328" y="5093208"/>
+            <a:ext cx="2834640" cy="274320"/>
+          </a:xfrm>
+          <a:prstGeom prst="rect">
+            <a:avLst/>
+          </a:prstGeom>
+          <a:noFill/>
+          <a:ln/>
+        </p:spPr>
+        <p:txBody>
+          <a:bodyPr wrap="square" lIns="0" tIns="0" rIns="0" bIns="0" rtlCol="0" anchor="ctr"/>
+          <a:lstStyle/>
+          <a:p>
+            <a:pPr indent="0" marL="0">
+              <a:buNone/>
+            </a:pPr>
+            <a:r>
+              <a:rPr lang="en-US" sz="1350" b="1" dirty="0">
+                <a:solidFill>
+                  <a:srgbClr val="FFFFFF"/>
+                </a:solidFill>
+                <a:latin typeface="Calibri" pitchFamily="34" charset="0"/>
+                <a:ea typeface="Calibri" pitchFamily="34" charset="-122"/>
+                <a:cs typeface="Calibri" pitchFamily="34" charset="-120"/>
+              </a:rPr>
+              <a:t>Entregar por valor</a:t>
+            </a:r>
+            <a:endParaRPr lang="en-US" sz="1350" dirty="0"/>
+          </a:p>
+        </p:txBody>
+      </p:sp>
+      <p:sp>
+        <p:nvSpPr>
+          <p:cNvPr id="23" name="Text 16"/>
+          <p:cNvSpPr/>
+          <p:nvPr/>
+        </p:nvSpPr>
+        <p:spPr>
+          <a:xfrm>
+            <a:off x="960120" y="5477256"/>
+            <a:ext cx="3355848" cy="438912"/>
+          </a:xfrm>
+          <a:prstGeom prst="rect">
+            <a:avLst/>
+          </a:prstGeom>
+          <a:noFill/>
+          <a:ln/>
+        </p:spPr>
+        <p:txBody>
+          <a:bodyPr wrap="square" lIns="0" tIns="0" rIns="0" bIns="0" rtlCol="0" anchor="ctr"/>
+          <a:lstStyle/>
+          <a:p>
+            <a:pPr indent="0" marL="0">
+              <a:lnSpc>
+                <a:spcPts val="1500"/>
+              </a:lnSpc>
+              <a:buNone/>
+            </a:pPr>
+            <a:r>
+              <a:rPr lang="en-US" sz="1100" dirty="0">
+                <a:solidFill>
+                  <a:srgbClr val="A9B2DC"/>
+                </a:solidFill>
+                <a:latin typeface="Calibri" pitchFamily="34" charset="0"/>
+                <a:ea typeface="Calibri" pitchFamily="34" charset="-122"/>
+                <a:cs typeface="Calibri" pitchFamily="34" charset="-120"/>
+              </a:rPr>
+              <a:t>Cada fase sale con algo que el cliente final nota.</a:t>
+            </a:r>
+            <a:endParaRPr lang="en-US" sz="1100" dirty="0"/>
+          </a:p>
+        </p:txBody>
+      </p:sp>
+      <p:sp>
+        <p:nvSpPr>
+          <p:cNvPr id="24" name="Shape 17"/>
+          <p:cNvSpPr/>
+          <p:nvPr/>
+        </p:nvSpPr>
+        <p:spPr>
+          <a:xfrm>
+            <a:off x="4846320" y="2148840"/>
+            <a:ext cx="6702552" cy="841248"/>
+          </a:xfrm>
+          <a:prstGeom prst="roundRect">
+            <a:avLst>
+              <a:gd name="adj" fmla="val 15217"/>
+            </a:avLst>
+          </a:prstGeom>
+          <a:solidFill>
+            <a:srgbClr val="18215C"/>
+          </a:solidFill>
+          <a:ln w="7620">
+            <a:solidFill>
+              <a:srgbClr val="FFFFFF">
+                <a:alpha val="12000"/>
+              </a:srgbClr>
+            </a:solidFill>
+            <a:prstDash val="solid"/>
+          </a:ln>
+          <a:effectLst>
+            <a:outerShdw sx="100000" sy="100000" kx="0" ky="0" algn="bl" rotWithShape="0" blurRad="177800" dist="50800" dir="5400000">
+              <a:srgbClr val="000000">
+                <a:alpha val="30000"/>
+              </a:srgbClr>
+            </a:outerShdw>
+          </a:effectLst>
+        </p:spPr>
+      </p:sp>
+      <p:sp>
+        <p:nvSpPr>
+          <p:cNvPr id="25" name="Shape 18"/>
+          <p:cNvSpPr/>
+          <p:nvPr/>
+        </p:nvSpPr>
+        <p:spPr>
+          <a:xfrm>
+            <a:off x="5120640" y="2386584"/>
+            <a:ext cx="365760" cy="365760"/>
+          </a:xfrm>
+          <a:prstGeom prst="ellipse">
+            <a:avLst/>
+          </a:prstGeom>
+          <a:solidFill>
+            <a:srgbClr val="F4610C"/>
+          </a:solidFill>
+          <a:ln w="12700">
+            <a:solidFill>
+              <a:srgbClr val="F4610C"/>
+            </a:solidFill>
+            <a:prstDash val="solid"/>
+          </a:ln>
+        </p:spPr>
+      </p:sp>
+      <p:sp>
+        <p:nvSpPr>
+          <p:cNvPr id="26" name="Text 19"/>
+          <p:cNvSpPr/>
+          <p:nvPr/>
+        </p:nvSpPr>
+        <p:spPr>
+          <a:xfrm>
+            <a:off x="5120640" y="2414016"/>
+            <a:ext cx="365760" cy="310896"/>
+          </a:xfrm>
+          <a:prstGeom prst="rect">
+            <a:avLst/>
+          </a:prstGeom>
+          <a:noFill/>
+          <a:ln/>
+        </p:spPr>
+        <p:txBody>
+          <a:bodyPr wrap="square" lIns="0" tIns="0" rIns="0" bIns="0" rtlCol="0" anchor="ctr"/>
+          <a:lstStyle/>
+          <a:p>
+            <a:pPr algn="ctr" indent="0" marL="0">
+              <a:buNone/>
+            </a:pPr>
+            <a:r>
+              <a:rPr lang="en-US" sz="1500" b="1" dirty="0">
+                <a:solidFill>
+                  <a:srgbClr val="FFFFFF"/>
+                </a:solidFill>
+                <a:latin typeface="Calibri" pitchFamily="34" charset="0"/>
+                <a:ea typeface="Calibri" pitchFamily="34" charset="-122"/>
+                <a:cs typeface="Calibri" pitchFamily="34" charset="-120"/>
+              </a:rPr>
+              <a:t>0</a:t>
+            </a:r>
+            <a:endParaRPr lang="en-US" sz="1500" dirty="0"/>
+          </a:p>
+        </p:txBody>
+      </p:sp>
+      <p:sp>
+        <p:nvSpPr>
+          <p:cNvPr id="27" name="Text 20"/>
+          <p:cNvSpPr/>
+          <p:nvPr/>
+        </p:nvSpPr>
+        <p:spPr>
+          <a:xfrm>
+            <a:off x="5623560" y="2267712"/>
+            <a:ext cx="3749040" cy="274320"/>
+          </a:xfrm>
+          <a:prstGeom prst="rect">
+            <a:avLst/>
+          </a:prstGeom>
+          <a:noFill/>
+          <a:ln/>
+        </p:spPr>
+        <p:txBody>
+          <a:bodyPr wrap="square" lIns="0" tIns="0" rIns="0" bIns="0" rtlCol="0" anchor="ctr"/>
+          <a:lstStyle/>
+          <a:p>
+            <a:pPr indent="0" marL="0">
+              <a:buNone/>
+            </a:pPr>
+            <a:r>
+              <a:rPr lang="en-US" sz="1400" b="1" dirty="0">
+                <a:solidFill>
+                  <a:srgbClr val="FFFFFF"/>
+                </a:solidFill>
+                <a:latin typeface="Calibri" pitchFamily="34" charset="0"/>
+                <a:ea typeface="Calibri" pitchFamily="34" charset="-122"/>
+                <a:cs typeface="Calibri" pitchFamily="34" charset="-120"/>
+              </a:rPr>
+              <a:t>Fase 0 · Descubrimiento</a:t>
+            </a:r>
+            <a:endParaRPr lang="en-US" sz="1400" dirty="0"/>
+          </a:p>
+        </p:txBody>
+      </p:sp>
+      <p:sp>
+        <p:nvSpPr>
+          <p:cNvPr id="28" name="Text 21"/>
+          <p:cNvSpPr/>
+          <p:nvPr/>
+        </p:nvSpPr>
+        <p:spPr>
+          <a:xfrm>
+            <a:off x="9418320" y="2267712"/>
+            <a:ext cx="1828800" cy="274320"/>
+          </a:xfrm>
+          <a:prstGeom prst="rect">
+            <a:avLst/>
+          </a:prstGeom>
+          <a:noFill/>
+          <a:ln/>
+        </p:spPr>
+        <p:txBody>
+          <a:bodyPr wrap="square" lIns="0" tIns="0" rIns="0" bIns="0" rtlCol="0" anchor="ctr"/>
+          <a:lstStyle/>
+          <a:p>
+            <a:pPr algn="r" indent="0" marL="0">
+              <a:buNone/>
+            </a:pPr>
+            <a:r>
+              <a:rPr lang="en-US" sz="1200" b="1" dirty="0">
+                <a:solidFill>
+                  <a:srgbClr val="FBA919"/>
+                </a:solidFill>
+                <a:latin typeface="Calibri" pitchFamily="34" charset="0"/>
+                <a:ea typeface="Calibri" pitchFamily="34" charset="-122"/>
+                <a:cs typeface="Calibri" pitchFamily="34" charset="-120"/>
+              </a:rPr>
+              <a:t>4 a 6 semanas</a:t>
+            </a:r>
+            <a:endParaRPr lang="en-US" sz="1200" dirty="0"/>
+          </a:p>
+        </p:txBody>
+      </p:sp>
+      <p:sp>
+        <p:nvSpPr>
+          <p:cNvPr id="29" name="Text 22"/>
+          <p:cNvSpPr/>
+          <p:nvPr/>
+        </p:nvSpPr>
+        <p:spPr>
+          <a:xfrm>
+            <a:off x="5623560" y="2578608"/>
+            <a:ext cx="5623560" cy="365760"/>
+          </a:xfrm>
+          <a:prstGeom prst="rect">
+            <a:avLst/>
+          </a:prstGeom>
+          <a:noFill/>
+          <a:ln/>
+        </p:spPr>
+        <p:txBody>
+          <a:bodyPr wrap="square" lIns="0" tIns="0" rIns="0" bIns="0" rtlCol="0" anchor="ctr"/>
+          <a:lstStyle/>
+          <a:p>
+            <a:pPr indent="0" marL="0">
+              <a:lnSpc>
+                <a:spcPts val="1500"/>
+              </a:lnSpc>
+              <a:buNone/>
+            </a:pPr>
+            <a:r>
+              <a:rPr lang="en-US" sz="1100" dirty="0">
+                <a:solidFill>
+                  <a:srgbClr val="A9B2DC"/>
+                </a:solidFill>
+                <a:latin typeface="Calibri" pitchFamily="34" charset="0"/>
+                <a:ea typeface="Calibri" pitchFamily="34" charset="-122"/>
+                <a:cs typeface="Calibri" pitchFamily="34" charset="-120"/>
+              </a:rPr>
+              <a:t>Inventario de sistemas y reglas reales, definición del ID único y arquitectura objetivo.</a:t>
+            </a:r>
+            <a:endParaRPr lang="en-US" sz="1100" dirty="0"/>
+          </a:p>
+        </p:txBody>
+      </p:sp>
+      <p:sp>
+        <p:nvSpPr>
+          <p:cNvPr id="30" name="Shape 23"/>
+          <p:cNvSpPr/>
+          <p:nvPr/>
+        </p:nvSpPr>
+        <p:spPr>
+          <a:xfrm>
+            <a:off x="4846320" y="3108960"/>
+            <a:ext cx="6702552" cy="841248"/>
+          </a:xfrm>
+          <a:prstGeom prst="roundRect">
+            <a:avLst>
+              <a:gd name="adj" fmla="val 15217"/>
+            </a:avLst>
+          </a:prstGeom>
+          <a:solidFill>
+            <a:srgbClr val="18215C"/>
+          </a:solidFill>
+          <a:ln w="7620">
+            <a:solidFill>
+              <a:srgbClr val="FFFFFF">
+                <a:alpha val="12000"/>
+              </a:srgbClr>
+            </a:solidFill>
+            <a:prstDash val="solid"/>
+          </a:ln>
+          <a:effectLst>
+            <a:outerShdw sx="100000" sy="100000" kx="0" ky="0" algn="bl" rotWithShape="0" blurRad="177800" dist="50800" dir="5400000">
+              <a:srgbClr val="000000">
+                <a:alpha val="30000"/>
+              </a:srgbClr>
+            </a:outerShdw>
+          </a:effectLst>
+        </p:spPr>
+      </p:sp>
+      <p:sp>
+        <p:nvSpPr>
+          <p:cNvPr id="31" name="Shape 24"/>
+          <p:cNvSpPr/>
+          <p:nvPr/>
+        </p:nvSpPr>
+        <p:spPr>
+          <a:xfrm>
+            <a:off x="5120640" y="3346704"/>
+            <a:ext cx="365760" cy="365760"/>
+          </a:xfrm>
+          <a:prstGeom prst="ellipse">
+            <a:avLst/>
+          </a:prstGeom>
+          <a:solidFill>
+            <a:srgbClr val="F4610C"/>
+          </a:solidFill>
+          <a:ln w="12700">
+            <a:solidFill>
+              <a:srgbClr val="F4610C"/>
+            </a:solidFill>
+            <a:prstDash val="solid"/>
+          </a:ln>
+        </p:spPr>
+      </p:sp>
+      <p:sp>
+        <p:nvSpPr>
+          <p:cNvPr id="32" name="Text 25"/>
+          <p:cNvSpPr/>
+          <p:nvPr/>
+        </p:nvSpPr>
+        <p:spPr>
+          <a:xfrm>
+            <a:off x="5120640" y="3374136"/>
+            <a:ext cx="365760" cy="310896"/>
+          </a:xfrm>
+          <a:prstGeom prst="rect">
+            <a:avLst/>
+          </a:prstGeom>
+          <a:noFill/>
+          <a:ln/>
+        </p:spPr>
+        <p:txBody>
+          <a:bodyPr wrap="square" lIns="0" tIns="0" rIns="0" bIns="0" rtlCol="0" anchor="ctr"/>
+          <a:lstStyle/>
+          <a:p>
+            <a:pPr algn="ctr" indent="0" marL="0">
+              <a:buNone/>
+            </a:pPr>
+            <a:r>
+              <a:rPr lang="en-US" sz="1500" b="1" dirty="0">
+                <a:solidFill>
+                  <a:srgbClr val="FFFFFF"/>
+                </a:solidFill>
+                <a:latin typeface="Calibri" pitchFamily="34" charset="0"/>
+                <a:ea typeface="Calibri" pitchFamily="34" charset="-122"/>
+                <a:cs typeface="Calibri" pitchFamily="34" charset="-120"/>
+              </a:rPr>
+              <a:t>1</a:t>
+            </a:r>
+            <a:endParaRPr lang="en-US" sz="1500" dirty="0"/>
+          </a:p>
+        </p:txBody>
+      </p:sp>
+      <p:sp>
+        <p:nvSpPr>
+          <p:cNvPr id="33" name="Text 26"/>
+          <p:cNvSpPr/>
+          <p:nvPr/>
+        </p:nvSpPr>
+        <p:spPr>
+          <a:xfrm>
+            <a:off x="5623560" y="3227832"/>
+            <a:ext cx="3749040" cy="274320"/>
+          </a:xfrm>
+          <a:prstGeom prst="rect">
+            <a:avLst/>
+          </a:prstGeom>
+          <a:noFill/>
+          <a:ln/>
+        </p:spPr>
+        <p:txBody>
+          <a:bodyPr wrap="square" lIns="0" tIns="0" rIns="0" bIns="0" rtlCol="0" anchor="ctr"/>
+          <a:lstStyle/>
+          <a:p>
+            <a:pPr indent="0" marL="0">
+              <a:buNone/>
+            </a:pPr>
+            <a:r>
+              <a:rPr lang="en-US" sz="1400" b="1" dirty="0">
+                <a:solidFill>
+                  <a:srgbClr val="FFFFFF"/>
+                </a:solidFill>
+                <a:latin typeface="Calibri" pitchFamily="34" charset="0"/>
+                <a:ea typeface="Calibri" pitchFamily="34" charset="-122"/>
+                <a:cs typeface="Calibri" pitchFamily="34" charset="-120"/>
+              </a:rPr>
+              <a:t>Fase 1 · Identidad y billetera</a:t>
+            </a:r>
+            <a:endParaRPr lang="en-US" sz="1400" dirty="0"/>
+          </a:p>
+        </p:txBody>
+      </p:sp>
+      <p:sp>
+        <p:nvSpPr>
+          <p:cNvPr id="34" name="Text 27"/>
+          <p:cNvSpPr/>
+          <p:nvPr/>
+        </p:nvSpPr>
+        <p:spPr>
+          <a:xfrm>
+            <a:off x="9418320" y="3227832"/>
+            <a:ext cx="1828800" cy="274320"/>
+          </a:xfrm>
+          <a:prstGeom prst="rect">
+            <a:avLst/>
+          </a:prstGeom>
+          <a:noFill/>
+          <a:ln/>
+        </p:spPr>
+        <p:txBody>
+          <a:bodyPr wrap="square" lIns="0" tIns="0" rIns="0" bIns="0" rtlCol="0" anchor="ctr"/>
+          <a:lstStyle/>
+          <a:p>
+            <a:pPr algn="r" indent="0" marL="0">
+              <a:buNone/>
+            </a:pPr>
+            <a:r>
+              <a:rPr lang="en-US" sz="1200" b="1" dirty="0">
+                <a:solidFill>
+                  <a:srgbClr val="FBA919"/>
+                </a:solidFill>
+                <a:latin typeface="Calibri" pitchFamily="34" charset="0"/>
+                <a:ea typeface="Calibri" pitchFamily="34" charset="-122"/>
+                <a:cs typeface="Calibri" pitchFamily="34" charset="-120"/>
+              </a:rPr>
+              <a:t>3 a 4 meses</a:t>
+            </a:r>
+            <a:endParaRPr lang="en-US" sz="1200" dirty="0"/>
+          </a:p>
+        </p:txBody>
+      </p:sp>
+      <p:sp>
+        <p:nvSpPr>
+          <p:cNvPr id="35" name="Text 28"/>
+          <p:cNvSpPr/>
+          <p:nvPr/>
+        </p:nvSpPr>
+        <p:spPr>
+          <a:xfrm>
+            <a:off x="5623560" y="3538728"/>
+            <a:ext cx="5623560" cy="365760"/>
+          </a:xfrm>
+          <a:prstGeom prst="rect">
+            <a:avLst/>
+          </a:prstGeom>
+          <a:noFill/>
+          <a:ln/>
+        </p:spPr>
+        <p:txBody>
+          <a:bodyPr wrap="square" lIns="0" tIns="0" rIns="0" bIns="0" rtlCol="0" anchor="ctr"/>
+          <a:lstStyle/>
+          <a:p>
+            <a:pPr indent="0" marL="0">
+              <a:lnSpc>
+                <a:spcPts val="1500"/>
+              </a:lnSpc>
+              <a:buNone/>
+            </a:pPr>
+            <a:r>
+              <a:rPr lang="en-US" sz="1100" dirty="0">
+                <a:solidFill>
+                  <a:srgbClr val="A9B2DC"/>
+                </a:solidFill>
+                <a:latin typeface="Calibri" pitchFamily="34" charset="0"/>
+                <a:ea typeface="Calibri" pitchFamily="34" charset="-122"/>
+                <a:cs typeface="Calibri" pitchFamily="34" charset="-120"/>
+              </a:rPr>
+              <a:t>Login único, vinculación de programas, saldo consolidado e historial. Piloto acotado.</a:t>
+            </a:r>
+            <a:endParaRPr lang="en-US" sz="1100" dirty="0"/>
+          </a:p>
+        </p:txBody>
+      </p:sp>
+      <p:sp>
+        <p:nvSpPr>
+          <p:cNvPr id="36" name="Shape 29"/>
+          <p:cNvSpPr/>
+          <p:nvPr/>
+        </p:nvSpPr>
+        <p:spPr>
+          <a:xfrm>
+            <a:off x="4846320" y="4069080"/>
+            <a:ext cx="6702552" cy="841248"/>
+          </a:xfrm>
+          <a:prstGeom prst="roundRect">
+            <a:avLst>
+              <a:gd name="adj" fmla="val 15217"/>
+            </a:avLst>
+          </a:prstGeom>
+          <a:solidFill>
+            <a:srgbClr val="18215C"/>
+          </a:solidFill>
+          <a:ln w="7620">
+            <a:solidFill>
+              <a:srgbClr val="FFFFFF">
+                <a:alpha val="12000"/>
+              </a:srgbClr>
+            </a:solidFill>
+            <a:prstDash val="solid"/>
+          </a:ln>
+          <a:effectLst>
+            <a:outerShdw sx="100000" sy="100000" kx="0" ky="0" algn="bl" rotWithShape="0" blurRad="177800" dist="50800" dir="5400000">
+              <a:srgbClr val="000000">
+                <a:alpha val="30000"/>
+              </a:srgbClr>
+            </a:outerShdw>
+          </a:effectLst>
+        </p:spPr>
+      </p:sp>
+      <p:sp>
+        <p:nvSpPr>
+          <p:cNvPr id="37" name="Shape 30"/>
+          <p:cNvSpPr/>
+          <p:nvPr/>
+        </p:nvSpPr>
+        <p:spPr>
+          <a:xfrm>
+            <a:off x="5120640" y="4306824"/>
+            <a:ext cx="365760" cy="365760"/>
+          </a:xfrm>
+          <a:prstGeom prst="ellipse">
+            <a:avLst/>
+          </a:prstGeom>
+          <a:solidFill>
+            <a:srgbClr val="F4610C"/>
+          </a:solidFill>
+          <a:ln w="12700">
+            <a:solidFill>
+              <a:srgbClr val="F4610C"/>
+            </a:solidFill>
+            <a:prstDash val="solid"/>
+          </a:ln>
+        </p:spPr>
+      </p:sp>
+      <p:sp>
+        <p:nvSpPr>
+          <p:cNvPr id="38" name="Text 31"/>
+          <p:cNvSpPr/>
+          <p:nvPr/>
+        </p:nvSpPr>
+        <p:spPr>
+          <a:xfrm>
+            <a:off x="5120640" y="4334256"/>
+            <a:ext cx="365760" cy="310896"/>
+          </a:xfrm>
+          <a:prstGeom prst="rect">
+            <a:avLst/>
+          </a:prstGeom>
+          <a:noFill/>
+          <a:ln/>
+        </p:spPr>
+        <p:txBody>
+          <a:bodyPr wrap="square" lIns="0" tIns="0" rIns="0" bIns="0" rtlCol="0" anchor="ctr"/>
+          <a:lstStyle/>
+          <a:p>
+            <a:pPr algn="ctr" indent="0" marL="0">
+              <a:buNone/>
+            </a:pPr>
+            <a:r>
+              <a:rPr lang="en-US" sz="1500" b="1" dirty="0">
+                <a:solidFill>
+                  <a:srgbClr val="FFFFFF"/>
+                </a:solidFill>
+                <a:latin typeface="Calibri" pitchFamily="34" charset="0"/>
+                <a:ea typeface="Calibri" pitchFamily="34" charset="-122"/>
+                <a:cs typeface="Calibri" pitchFamily="34" charset="-120"/>
+              </a:rPr>
+              <a:t>2</a:t>
+            </a:r>
+            <a:endParaRPr lang="en-US" sz="1500" dirty="0"/>
+          </a:p>
+        </p:txBody>
+      </p:sp>
+      <p:sp>
+        <p:nvSpPr>
+          <p:cNvPr id="39" name="Text 32"/>
+          <p:cNvSpPr/>
+          <p:nvPr/>
+        </p:nvSpPr>
+        <p:spPr>
+          <a:xfrm>
+            <a:off x="5623560" y="4187952"/>
+            <a:ext cx="3749040" cy="274320"/>
+          </a:xfrm>
+          <a:prstGeom prst="rect">
+            <a:avLst/>
+          </a:prstGeom>
+          <a:noFill/>
+          <a:ln/>
+        </p:spPr>
+        <p:txBody>
+          <a:bodyPr wrap="square" lIns="0" tIns="0" rIns="0" bIns="0" rtlCol="0" anchor="ctr"/>
+          <a:lstStyle/>
+          <a:p>
+            <a:pPr indent="0" marL="0">
+              <a:buNone/>
+            </a:pPr>
+            <a:r>
+              <a:rPr lang="en-US" sz="1400" b="1" dirty="0">
+                <a:solidFill>
+                  <a:srgbClr val="FFFFFF"/>
+                </a:solidFill>
+                <a:latin typeface="Calibri" pitchFamily="34" charset="0"/>
+                <a:ea typeface="Calibri" pitchFamily="34" charset="-122"/>
+                <a:cs typeface="Calibri" pitchFamily="34" charset="-120"/>
+              </a:rPr>
+              <a:t>Fase 2 · Pago y motor de beneficios</a:t>
+            </a:r>
+            <a:endParaRPr lang="en-US" sz="1400" dirty="0"/>
+          </a:p>
+        </p:txBody>
+      </p:sp>
+      <p:sp>
+        <p:nvSpPr>
+          <p:cNvPr id="40" name="Text 33"/>
+          <p:cNvSpPr/>
+          <p:nvPr/>
+        </p:nvSpPr>
+        <p:spPr>
+          <a:xfrm>
+            <a:off x="9418320" y="4187952"/>
+            <a:ext cx="1828800" cy="274320"/>
+          </a:xfrm>
+          <a:prstGeom prst="rect">
+            <a:avLst/>
+          </a:prstGeom>
+          <a:noFill/>
+          <a:ln/>
+        </p:spPr>
+        <p:txBody>
+          <a:bodyPr wrap="square" lIns="0" tIns="0" rIns="0" bIns="0" rtlCol="0" anchor="ctr"/>
+          <a:lstStyle/>
+          <a:p>
+            <a:pPr algn="r" indent="0" marL="0">
+              <a:buNone/>
+            </a:pPr>
+            <a:r>
+              <a:rPr lang="en-US" sz="1200" b="1" dirty="0">
+                <a:solidFill>
+                  <a:srgbClr val="FBA919"/>
+                </a:solidFill>
+                <a:latin typeface="Calibri" pitchFamily="34" charset="0"/>
+                <a:ea typeface="Calibri" pitchFamily="34" charset="-122"/>
+                <a:cs typeface="Calibri" pitchFamily="34" charset="-120"/>
+              </a:rPr>
+              <a:t>3 a 4 meses</a:t>
+            </a:r>
+            <a:endParaRPr lang="en-US" sz="1200" dirty="0"/>
+          </a:p>
+        </p:txBody>
+      </p:sp>
+      <p:sp>
+        <p:nvSpPr>
+          <p:cNvPr id="41" name="Text 34"/>
+          <p:cNvSpPr/>
+          <p:nvPr/>
+        </p:nvSpPr>
+        <p:spPr>
+          <a:xfrm>
+            <a:off x="5623560" y="4498848"/>
+            <a:ext cx="5623560" cy="365760"/>
+          </a:xfrm>
+          <a:prstGeom prst="rect">
+            <a:avLst/>
+          </a:prstGeom>
+          <a:noFill/>
+          <a:ln/>
+        </p:spPr>
+        <p:txBody>
+          <a:bodyPr wrap="square" lIns="0" tIns="0" rIns="0" bIns="0" rtlCol="0" anchor="ctr"/>
+          <a:lstStyle/>
+          <a:p>
+            <a:pPr indent="0" marL="0">
+              <a:lnSpc>
+                <a:spcPts val="1500"/>
+              </a:lnSpc>
+              <a:buNone/>
+            </a:pPr>
+            <a:r>
+              <a:rPr lang="en-US" sz="1100" dirty="0">
+                <a:solidFill>
+                  <a:srgbClr val="A9B2DC"/>
+                </a:solidFill>
+                <a:latin typeface="Calibri" pitchFamily="34" charset="0"/>
+                <a:ea typeface="Calibri" pitchFamily="34" charset="-122"/>
+                <a:cs typeface="Calibri" pitchFamily="34" charset="-120"/>
+              </a:rPr>
+              <a:t>QR único integrado al POS. Convenio, sellos y BonusPaga resueltos en una sola transacción.</a:t>
+            </a:r>
+            <a:endParaRPr lang="en-US" sz="1100" dirty="0"/>
+          </a:p>
+        </p:txBody>
+      </p:sp>
+      <p:sp>
+        <p:nvSpPr>
+          <p:cNvPr id="42" name="Shape 35"/>
+          <p:cNvSpPr/>
+          <p:nvPr/>
+        </p:nvSpPr>
+        <p:spPr>
+          <a:xfrm>
+            <a:off x="4846320" y="5029200"/>
+            <a:ext cx="6702552" cy="841248"/>
+          </a:xfrm>
+          <a:prstGeom prst="roundRect">
+            <a:avLst>
+              <a:gd name="adj" fmla="val 15217"/>
+            </a:avLst>
+          </a:prstGeom>
+          <a:solidFill>
+            <a:srgbClr val="18215C"/>
+          </a:solidFill>
+          <a:ln w="7620">
+            <a:solidFill>
+              <a:srgbClr val="FFFFFF">
+                <a:alpha val="12000"/>
+              </a:srgbClr>
+            </a:solidFill>
+            <a:prstDash val="solid"/>
+          </a:ln>
+          <a:effectLst>
+            <a:outerShdw sx="100000" sy="100000" kx="0" ky="0" algn="bl" rotWithShape="0" blurRad="177800" dist="50800" dir="5400000">
+              <a:srgbClr val="000000">
+                <a:alpha val="30000"/>
+              </a:srgbClr>
+            </a:outerShdw>
+          </a:effectLst>
+        </p:spPr>
+      </p:sp>
+      <p:sp>
+        <p:nvSpPr>
+          <p:cNvPr id="43" name="Shape 36"/>
+          <p:cNvSpPr/>
+          <p:nvPr/>
+        </p:nvSpPr>
+        <p:spPr>
+          <a:xfrm>
+            <a:off x="5120640" y="5266944"/>
+            <a:ext cx="365760" cy="365760"/>
+          </a:xfrm>
+          <a:prstGeom prst="ellipse">
+            <a:avLst/>
+          </a:prstGeom>
+          <a:solidFill>
+            <a:srgbClr val="F4610C"/>
+          </a:solidFill>
+          <a:ln w="12700">
+            <a:solidFill>
+              <a:srgbClr val="F4610C"/>
+            </a:solidFill>
+            <a:prstDash val="solid"/>
+          </a:ln>
+        </p:spPr>
+      </p:sp>
+      <p:sp>
+        <p:nvSpPr>
+          <p:cNvPr id="44" name="Text 37"/>
+          <p:cNvSpPr/>
+          <p:nvPr/>
+        </p:nvSpPr>
+        <p:spPr>
+          <a:xfrm>
+            <a:off x="5120640" y="5294376"/>
+            <a:ext cx="365760" cy="310896"/>
+          </a:xfrm>
+          <a:prstGeom prst="rect">
+            <a:avLst/>
+          </a:prstGeom>
+          <a:noFill/>
+          <a:ln/>
+        </p:spPr>
+        <p:txBody>
+          <a:bodyPr wrap="square" lIns="0" tIns="0" rIns="0" bIns="0" rtlCol="0" anchor="ctr"/>
+          <a:lstStyle/>
+          <a:p>
+            <a:pPr algn="ctr" indent="0" marL="0">
+              <a:buNone/>
+            </a:pPr>
+            <a:r>
+              <a:rPr lang="en-US" sz="1500" b="1" dirty="0">
+                <a:solidFill>
+                  <a:srgbClr val="FFFFFF"/>
+                </a:solidFill>
+                <a:latin typeface="Calibri" pitchFamily="34" charset="0"/>
+                <a:ea typeface="Calibri" pitchFamily="34" charset="-122"/>
+                <a:cs typeface="Calibri" pitchFamily="34" charset="-120"/>
+              </a:rPr>
+              <a:t>3</a:t>
+            </a:r>
+            <a:endParaRPr lang="en-US" sz="1500" dirty="0"/>
+          </a:p>
+        </p:txBody>
+      </p:sp>
+      <p:sp>
+        <p:nvSpPr>
+          <p:cNvPr id="45" name="Text 38"/>
+          <p:cNvSpPr/>
+          <p:nvPr/>
+        </p:nvSpPr>
+        <p:spPr>
+          <a:xfrm>
+            <a:off x="5623560" y="5148072"/>
+            <a:ext cx="3749040" cy="274320"/>
+          </a:xfrm>
+          <a:prstGeom prst="rect">
+            <a:avLst/>
+          </a:prstGeom>
+          <a:noFill/>
+          <a:ln/>
+        </p:spPr>
+        <p:txBody>
+          <a:bodyPr wrap="square" lIns="0" tIns="0" rIns="0" bIns="0" rtlCol="0" anchor="ctr"/>
+          <a:lstStyle/>
+          <a:p>
+            <a:pPr indent="0" marL="0">
+              <a:buNone/>
+            </a:pPr>
+            <a:r>
+              <a:rPr lang="en-US" sz="1400" b="1" dirty="0">
+                <a:solidFill>
+                  <a:srgbClr val="FFFFFF"/>
+                </a:solidFill>
+                <a:latin typeface="Calibri" pitchFamily="34" charset="0"/>
+                <a:ea typeface="Calibri" pitchFamily="34" charset="-122"/>
+                <a:cs typeface="Calibri" pitchFamily="34" charset="-120"/>
+              </a:rPr>
+              <a:t>Fase 3 · Engagement y expansión</a:t>
+            </a:r>
+            <a:endParaRPr lang="en-US" sz="1400" dirty="0"/>
+          </a:p>
+        </p:txBody>
+      </p:sp>
+      <p:sp>
+        <p:nvSpPr>
+          <p:cNvPr id="46" name="Text 39"/>
+          <p:cNvSpPr/>
+          <p:nvPr/>
+        </p:nvSpPr>
+        <p:spPr>
+          <a:xfrm>
+            <a:off x="9418320" y="5148072"/>
+            <a:ext cx="1828800" cy="274320"/>
+          </a:xfrm>
+          <a:prstGeom prst="rect">
+            <a:avLst/>
+          </a:prstGeom>
+          <a:noFill/>
+          <a:ln/>
+        </p:spPr>
+        <p:txBody>
+          <a:bodyPr wrap="square" lIns="0" tIns="0" rIns="0" bIns="0" rtlCol="0" anchor="ctr"/>
+          <a:lstStyle/>
+          <a:p>
+            <a:pPr algn="r" indent="0" marL="0">
+              <a:buNone/>
+            </a:pPr>
+            <a:r>
+              <a:rPr lang="en-US" sz="1200" b="1" dirty="0">
+                <a:solidFill>
+                  <a:srgbClr val="FBA919"/>
+                </a:solidFill>
+                <a:latin typeface="Calibri" pitchFamily="34" charset="0"/>
+                <a:ea typeface="Calibri" pitchFamily="34" charset="-122"/>
+                <a:cs typeface="Calibri" pitchFamily="34" charset="-120"/>
+              </a:rPr>
+              <a:t>continuo</a:t>
+            </a:r>
+            <a:endParaRPr lang="en-US" sz="1200" dirty="0"/>
+          </a:p>
+        </p:txBody>
+      </p:sp>
+      <p:sp>
+        <p:nvSpPr>
+          <p:cNvPr id="47" name="Text 40"/>
+          <p:cNvSpPr/>
+          <p:nvPr/>
+        </p:nvSpPr>
+        <p:spPr>
+          <a:xfrm>
+            <a:off x="5623560" y="5458968"/>
+            <a:ext cx="5623560" cy="365760"/>
+          </a:xfrm>
+          <a:prstGeom prst="rect">
+            <a:avLst/>
+          </a:prstGeom>
+          <a:noFill/>
+          <a:ln/>
+        </p:spPr>
+        <p:txBody>
+          <a:bodyPr wrap="square" lIns="0" tIns="0" rIns="0" bIns="0" rtlCol="0" anchor="ctr"/>
+          <a:lstStyle/>
+          <a:p>
+            <a:pPr indent="0" marL="0">
+              <a:lnSpc>
+                <a:spcPts val="1500"/>
+              </a:lnSpc>
+              <a:buNone/>
+            </a:pPr>
+            <a:r>
+              <a:rPr lang="en-US" sz="1100" dirty="0">
+                <a:solidFill>
+                  <a:srgbClr val="A9B2DC"/>
+                </a:solidFill>
+                <a:latin typeface="Calibri" pitchFamily="34" charset="0"/>
+                <a:ea typeface="Calibri" pitchFamily="34" charset="-122"/>
+                <a:cs typeface="Calibri" pitchFamily="34" charset="-120"/>
+              </a:rPr>
+              <a:t>Retos, gamificación y personalización. Gas y lubricantes entran al mismo flujo.</a:t>
+            </a:r>
+            <a:endParaRPr lang="en-US" sz="1100" dirty="0"/>
+          </a:p>
+        </p:txBody>
+      </p:sp>
+      <p:sp>
+        <p:nvSpPr>
+          <p:cNvPr id="48" name="Text 41"/>
+          <p:cNvSpPr/>
+          <p:nvPr/>
+        </p:nvSpPr>
+        <p:spPr>
+          <a:xfrm>
+            <a:off x="640080" y="6153912"/>
+            <a:ext cx="10911535" cy="411480"/>
+          </a:xfrm>
+          <a:prstGeom prst="rect">
+            <a:avLst/>
+          </a:prstGeom>
+          <a:noFill/>
+          <a:ln/>
+        </p:spPr>
+        <p:txBody>
+          <a:bodyPr wrap="square" lIns="0" tIns="0" rIns="0" bIns="0" rtlCol="0" anchor="ctr"/>
+          <a:lstStyle/>
+          <a:p>
+            <a:pPr indent="0" marL="0">
+              <a:buNone/>
+            </a:pPr>
+            <a:r>
+              <a:rPr lang="en-US" sz="1200" i="1" dirty="0">
+                <a:solidFill>
+                  <a:srgbClr val="7F8AC0"/>
+                </a:solidFill>
+                <a:latin typeface="Calibri" pitchFamily="34" charset="0"/>
+                <a:ea typeface="Calibri" pitchFamily="34" charset="-122"/>
+                <a:cs typeface="Calibri" pitchFamily="34" charset="-120"/>
+              </a:rPr>
+              <a:t>Plazos estimados, para dimensionar. Bonus es un programa de consorcio con Cencosud y Delosi: se integra, no se absorbe — el enfoque lo respeta desde el primer día.</a:t>
+            </a:r>
+            <a:endParaRPr lang="en-US" sz="1200" dirty="0"/>
+          </a:p>
+        </p:txBody>
+      </p:sp>
+    </p:spTree>
+  </p:cSld>
+  <p:clrMapOvr>
+    <a:masterClrMapping/>
+  </p:clrMapOvr>
+</p:sld>
+</file>
+
+<file path=ppt/slides/slide7.xml><?xml version="1.0" encoding="utf-8"?>
+<p:sld xmlns:a="http://schemas.openxmlformats.org/drawingml/2006/main" xmlns:r="http://schemas.openxmlformats.org/officeDocument/2006/relationships" xmlns:p="http://schemas.openxmlformats.org/presentationml/2006/main">
+  <p:cSld name="Slide 7">
+    <p:bg>
+      <p:bgPr>
+        <a:blipFill dpi="0" rotWithShape="1">
+          <a:blip r:embed="rId1">
+            <a:lum/>
+          </a:blip>
+          <a:srcRect/>
+          <a:stretch>
+            <a:fillRect/>
+          </a:stretch>
+        </a:blipFill>
+        <a:effectLst/>
+      </p:bgPr>
+    </p:bg>
+    <p:spTree>
+      <p:nvGrpSpPr>
+        <p:cNvPr id="1" name=""/>
+        <p:cNvGrpSpPr/>
+        <p:nvPr/>
+      </p:nvGrpSpPr>
+      <p:grpSpPr>
+        <a:xfrm>
+          <a:off x="0" y="0"/>
+          <a:ext cx="0" cy="0"/>
+          <a:chOff x="0" y="0"/>
+          <a:chExt cx="0" cy="0"/>
+        </a:xfrm>
+      </p:grpSpPr>
+      <p:sp>
+        <p:nvSpPr>
+          <p:cNvPr id="2" name="Text 0"/>
+          <p:cNvSpPr/>
+          <p:nvPr/>
+        </p:nvSpPr>
+        <p:spPr>
+          <a:xfrm>
+            <a:off x="640080" y="457200"/>
+            <a:ext cx="5486400" cy="274320"/>
+          </a:xfrm>
+          <a:prstGeom prst="rect">
+            <a:avLst/>
+          </a:prstGeom>
+          <a:noFill/>
+          <a:ln/>
+        </p:spPr>
+        <p:txBody>
+          <a:bodyPr wrap="square" lIns="0" tIns="0" rIns="0" bIns="0" rtlCol="0" anchor="ctr"/>
+          <a:lstStyle/>
+          <a:p>
+            <a:pPr indent="0" marL="0">
+              <a:buNone/>
+            </a:pPr>
+            <a:r>
+              <a:rPr lang="en-US" sz="1150" b="1" spc="240" kern="0" dirty="0">
+                <a:solidFill>
+                  <a:srgbClr val="FBA919"/>
+                </a:solidFill>
+                <a:latin typeface="Calibri" pitchFamily="34" charset="0"/>
+                <a:ea typeface="Calibri" pitchFamily="34" charset="-122"/>
+                <a:cs typeface="Calibri" pitchFamily="34" charset="-120"/>
+              </a:rPr>
+              <a:t>CÓMO SE CONSTRUYE</a:t>
+            </a:r>
+            <a:endParaRPr lang="en-US" sz="1150" dirty="0"/>
+          </a:p>
+        </p:txBody>
+      </p:sp>
+      <p:sp>
+        <p:nvSpPr>
+          <p:cNvPr id="3" name="Text 1"/>
+          <p:cNvSpPr/>
+          <p:nvPr/>
+        </p:nvSpPr>
+        <p:spPr>
+          <a:xfrm>
+            <a:off x="640080" y="777240"/>
+            <a:ext cx="9326880" cy="914400"/>
+          </a:xfrm>
+          <a:prstGeom prst="rect">
+            <a:avLst/>
+          </a:prstGeom>
+          <a:noFill/>
+          <a:ln/>
+        </p:spPr>
+        <p:txBody>
+          <a:bodyPr wrap="square" lIns="0" tIns="0" rIns="0" bIns="0" rtlCol="0" anchor="t"/>
+          <a:lstStyle/>
+          <a:p>
+            <a:pPr indent="0" marL="0">
+              <a:lnSpc>
+                <a:spcPts val="3800"/>
+              </a:lnSpc>
+              <a:buNone/>
+            </a:pPr>
+            <a:r>
+              <a:rPr lang="en-US" sz="3300" b="1" dirty="0">
+                <a:solidFill>
+                  <a:srgbClr val="FFFFFF"/>
+                </a:solidFill>
+                <a:latin typeface="Calibri" pitchFamily="34" charset="0"/>
+                <a:ea typeface="Calibri" pitchFamily="34" charset="-122"/>
+                <a:cs typeface="Calibri" pitchFamily="34" charset="-120"/>
+              </a:rPr>
+              <a:t>Una capa de orquestación sobre lo que ya existe</a:t>
+            </a:r>
+            <a:endParaRPr lang="en-US" sz="3300" dirty="0"/>
+          </a:p>
+        </p:txBody>
+      </p:sp>
+      <p:sp>
+        <p:nvSpPr>
+          <p:cNvPr id="4" name="Text 2"/>
+          <p:cNvSpPr/>
+          <p:nvPr/>
+        </p:nvSpPr>
+        <p:spPr>
+          <a:xfrm>
+            <a:off x="640080" y="1709928"/>
+            <a:ext cx="9692640" cy="310896"/>
+          </a:xfrm>
+          <a:prstGeom prst="rect">
+            <a:avLst/>
+          </a:prstGeom>
+          <a:noFill/>
+          <a:ln/>
+        </p:spPr>
+        <p:txBody>
+          <a:bodyPr wrap="square" lIns="0" tIns="0" rIns="0" bIns="0" rtlCol="0" anchor="ctr"/>
+          <a:lstStyle/>
+          <a:p>
+            <a:pPr indent="0" marL="0">
+              <a:buNone/>
+            </a:pPr>
+            <a:r>
+              <a:rPr lang="en-US" sz="1350" dirty="0">
+                <a:solidFill>
+                  <a:srgbClr val="A9B2DC"/>
+                </a:solidFill>
+                <a:latin typeface="Calibri" pitchFamily="34" charset="0"/>
+                <a:ea typeface="Calibri" pitchFamily="34" charset="-122"/>
+                <a:cs typeface="Calibri" pitchFamily="34" charset="-120"/>
+              </a:rPr>
+              <a:t>La app no reemplaza a Bonus, a Convenios ni al POS de la estación: los coordina detrás de una sola experiencia.</a:t>
+            </a:r>
+            <a:endParaRPr lang="en-US" sz="1350" dirty="0"/>
+          </a:p>
+        </p:txBody>
+      </p:sp>
+      <p:sp>
+        <p:nvSpPr>
+          <p:cNvPr id="5" name="Shape 3"/>
+          <p:cNvSpPr/>
+          <p:nvPr/>
+        </p:nvSpPr>
+        <p:spPr>
+          <a:xfrm>
+            <a:off x="10515600" y="457200"/>
+            <a:ext cx="1325880" cy="658368"/>
+          </a:xfrm>
+          <a:prstGeom prst="roundRect">
+            <a:avLst>
+              <a:gd name="adj" fmla="val 13889"/>
+            </a:avLst>
+          </a:prstGeom>
+          <a:solidFill>
+            <a:srgbClr val="FFFFFF"/>
+          </a:solidFill>
+          <a:ln/>
+        </p:spPr>
+      </p:sp>
+      <p:pic>
+        <p:nvPicPr>
+          <p:cNvPr id="6" name="Image 0" descr="C:/Users/Axel/Documents/Axel/Repos Claude/cx-demo-app/public/logo-wordmark.jpg">    </p:cNvPr>
+          <p:cNvPicPr>
+            <a:picLocks noChangeAspect="1"/>
+          </p:cNvPicPr>
+          <p:nvPr/>
+        </p:nvPicPr>
+        <p:blipFill>
+          <a:blip r:embed="rId2"/>
+          <a:stretch>
+            <a:fillRect/>
+          </a:stretch>
+        </p:blipFill>
+        <p:spPr>
+          <a:xfrm>
+            <a:off x="10616184" y="576072"/>
+            <a:ext cx="1124712" cy="420624"/>
+          </a:xfrm>
+          <a:prstGeom prst="rect">
+            <a:avLst/>
+          </a:prstGeom>
+        </p:spPr>
+      </p:pic>
+      <p:sp>
+        <p:nvSpPr>
+          <p:cNvPr id="7" name="Text 4"/>
+          <p:cNvSpPr/>
+          <p:nvPr/>
+        </p:nvSpPr>
+        <p:spPr>
+          <a:xfrm>
+            <a:off x="640080" y="2148840"/>
+            <a:ext cx="6903720" cy="219456"/>
+          </a:xfrm>
+          <a:prstGeom prst="rect">
+            <a:avLst/>
+          </a:prstGeom>
+          <a:noFill/>
+          <a:ln/>
+        </p:spPr>
+        <p:txBody>
+          <a:bodyPr wrap="square" lIns="0" tIns="0" rIns="0" bIns="0" rtlCol="0" anchor="ctr"/>
+          <a:lstStyle/>
+          <a:p>
+            <a:pPr indent="0" marL="0">
+              <a:buNone/>
+            </a:pPr>
+            <a:r>
+              <a:rPr lang="en-US" sz="1000" b="1" spc="180" kern="0" dirty="0">
+                <a:solidFill>
+                  <a:srgbClr val="FBA919"/>
+                </a:solidFill>
+                <a:latin typeface="Calibri" pitchFamily="34" charset="0"/>
+                <a:ea typeface="Calibri" pitchFamily="34" charset="-122"/>
+                <a:cs typeface="Calibri" pitchFamily="34" charset="-120"/>
+              </a:rPr>
+              <a:t>EXPERIENCIA</a:t>
+            </a:r>
+            <a:endParaRPr lang="en-US" sz="1000" dirty="0"/>
+          </a:p>
+        </p:txBody>
+      </p:sp>
+      <p:sp>
+        <p:nvSpPr>
+          <p:cNvPr id="8" name="Shape 5"/>
+          <p:cNvSpPr/>
+          <p:nvPr/>
+        </p:nvSpPr>
+        <p:spPr>
+          <a:xfrm>
+            <a:off x="640080" y="2377440"/>
+            <a:ext cx="6903720" cy="457200"/>
+          </a:xfrm>
+          <a:prstGeom prst="roundRect">
+            <a:avLst>
+              <a:gd name="adj" fmla="val 28000"/>
+            </a:avLst>
+          </a:prstGeom>
+          <a:solidFill>
+            <a:srgbClr val="18215C"/>
+          </a:solidFill>
+          <a:ln w="7620">
+            <a:solidFill>
+              <a:srgbClr val="FFFFFF">
+                <a:alpha val="12000"/>
+              </a:srgbClr>
+            </a:solidFill>
+            <a:prstDash val="solid"/>
+          </a:ln>
+          <a:effectLst>
+            <a:outerShdw sx="100000" sy="100000" kx="0" ky="0" algn="bl" rotWithShape="0" blurRad="177800" dist="50800" dir="5400000">
+              <a:srgbClr val="000000">
+                <a:alpha val="30000"/>
+              </a:srgbClr>
+            </a:outerShdw>
+          </a:effectLst>
+        </p:spPr>
+      </p:sp>
+      <p:sp>
+        <p:nvSpPr>
+          <p:cNvPr id="9" name="Text 6"/>
+          <p:cNvSpPr/>
+          <p:nvPr/>
+        </p:nvSpPr>
+        <p:spPr>
+          <a:xfrm>
+            <a:off x="640080" y="2377440"/>
+            <a:ext cx="6903720" cy="457200"/>
+          </a:xfrm>
+          <a:prstGeom prst="rect">
+            <a:avLst/>
+          </a:prstGeom>
+          <a:noFill/>
+          <a:ln/>
+        </p:spPr>
+        <p:txBody>
+          <a:bodyPr wrap="square" lIns="0" tIns="0" rIns="0" bIns="0" rtlCol="0" anchor="ctr"/>
+          <a:lstStyle/>
+          <a:p>
+            <a:pPr algn="ctr" indent="0" marL="0">
+              <a:buNone/>
+            </a:pPr>
+            <a:r>
+              <a:rPr lang="en-US" sz="1300" b="1" dirty="0">
+                <a:solidFill>
+                  <a:srgbClr val="FFFFFF"/>
+                </a:solidFill>
+                <a:latin typeface="Calibri" pitchFamily="34" charset="0"/>
+                <a:ea typeface="Calibri" pitchFamily="34" charset="-122"/>
+                <a:cs typeface="Calibri" pitchFamily="34" charset="-120"/>
+              </a:rPr>
+              <a:t>App Primax ID · una sola app para el cliente final</a:t>
+            </a:r>
+            <a:endParaRPr lang="en-US" sz="1300" dirty="0"/>
+          </a:p>
+        </p:txBody>
+      </p:sp>
+      <p:sp>
+        <p:nvSpPr>
+          <p:cNvPr id="10" name="Text 7"/>
+          <p:cNvSpPr/>
+          <p:nvPr/>
+        </p:nvSpPr>
+        <p:spPr>
+          <a:xfrm>
+            <a:off x="640080" y="2980944"/>
+            <a:ext cx="6903720" cy="219456"/>
+          </a:xfrm>
+          <a:prstGeom prst="rect">
+            <a:avLst/>
+          </a:prstGeom>
+          <a:noFill/>
+          <a:ln/>
+        </p:spPr>
+        <p:txBody>
+          <a:bodyPr wrap="square" lIns="0" tIns="0" rIns="0" bIns="0" rtlCol="0" anchor="ctr"/>
+          <a:lstStyle/>
+          <a:p>
+            <a:pPr indent="0" marL="0">
+              <a:buNone/>
+            </a:pPr>
+            <a:r>
+              <a:rPr lang="en-US" sz="1000" b="1" spc="180" kern="0" dirty="0">
+                <a:solidFill>
+                  <a:srgbClr val="FBA919"/>
+                </a:solidFill>
+                <a:latin typeface="Calibri" pitchFamily="34" charset="0"/>
+                <a:ea typeface="Calibri" pitchFamily="34" charset="-122"/>
+                <a:cs typeface="Calibri" pitchFamily="34" charset="-120"/>
+              </a:rPr>
+              <a:t>ORQUESTACIÓN</a:t>
+            </a:r>
+            <a:endParaRPr lang="en-US" sz="1000" dirty="0"/>
+          </a:p>
+        </p:txBody>
+      </p:sp>
+      <p:sp>
+        <p:nvSpPr>
+          <p:cNvPr id="11" name="Shape 8"/>
+          <p:cNvSpPr/>
+          <p:nvPr/>
+        </p:nvSpPr>
+        <p:spPr>
+          <a:xfrm>
+            <a:off x="640080" y="3209544"/>
+            <a:ext cx="6903720" cy="457200"/>
+          </a:xfrm>
+          <a:prstGeom prst="roundRect">
+            <a:avLst>
+              <a:gd name="adj" fmla="val 28000"/>
+            </a:avLst>
+          </a:prstGeom>
+          <a:solidFill>
+            <a:srgbClr val="18215C"/>
+          </a:solidFill>
+          <a:ln w="7620">
+            <a:solidFill>
+              <a:srgbClr val="FFFFFF">
+                <a:alpha val="12000"/>
+              </a:srgbClr>
+            </a:solidFill>
+            <a:prstDash val="solid"/>
+          </a:ln>
+          <a:effectLst>
+            <a:outerShdw sx="100000" sy="100000" kx="0" ky="0" algn="bl" rotWithShape="0" blurRad="177800" dist="50800" dir="5400000">
+              <a:srgbClr val="000000">
+                <a:alpha val="30000"/>
+              </a:srgbClr>
+            </a:outerShdw>
+          </a:effectLst>
+        </p:spPr>
+      </p:sp>
+      <p:sp>
+        <p:nvSpPr>
+          <p:cNvPr id="12" name="Text 9"/>
+          <p:cNvSpPr/>
+          <p:nvPr/>
+        </p:nvSpPr>
+        <p:spPr>
+          <a:xfrm>
+            <a:off x="640080" y="3209544"/>
+            <a:ext cx="6903720" cy="457200"/>
+          </a:xfrm>
+          <a:prstGeom prst="rect">
+            <a:avLst/>
+          </a:prstGeom>
+          <a:noFill/>
+          <a:ln/>
+        </p:spPr>
+        <p:txBody>
+          <a:bodyPr wrap="square" lIns="0" tIns="0" rIns="0" bIns="0" rtlCol="0" anchor="ctr"/>
+          <a:lstStyle/>
+          <a:p>
+            <a:pPr algn="ctr" indent="0" marL="0">
+              <a:buNone/>
+            </a:pPr>
+            <a:r>
+              <a:rPr lang="en-US" sz="1250" dirty="0">
+                <a:solidFill>
+                  <a:srgbClr val="FFFFFF"/>
+                </a:solidFill>
+                <a:latin typeface="Calibri" pitchFamily="34" charset="0"/>
+                <a:ea typeface="Calibri" pitchFamily="34" charset="-122"/>
+                <a:cs typeface="Calibri" pitchFamily="34" charset="-120"/>
+              </a:rPr>
+              <a:t>API única (BFF) · contratos versionados, una sola integración para el front</a:t>
+            </a:r>
+            <a:endParaRPr lang="en-US" sz="1250" dirty="0"/>
+          </a:p>
+        </p:txBody>
+      </p:sp>
+      <p:sp>
+        <p:nvSpPr>
+          <p:cNvPr id="13" name="Text 10"/>
+          <p:cNvSpPr/>
+          <p:nvPr/>
+        </p:nvSpPr>
+        <p:spPr>
+          <a:xfrm>
+            <a:off x="640080" y="3813048"/>
+            <a:ext cx="6903720" cy="219456"/>
+          </a:xfrm>
+          <a:prstGeom prst="rect">
+            <a:avLst/>
+          </a:prstGeom>
+          <a:noFill/>
+          <a:ln/>
+        </p:spPr>
+        <p:txBody>
+          <a:bodyPr wrap="square" lIns="0" tIns="0" rIns="0" bIns="0" rtlCol="0" anchor="ctr"/>
+          <a:lstStyle/>
+          <a:p>
+            <a:pPr indent="0" marL="0">
+              <a:buNone/>
+            </a:pPr>
+            <a:r>
+              <a:rPr lang="en-US" sz="1000" b="1" spc="180" kern="0" dirty="0">
+                <a:solidFill>
+                  <a:srgbClr val="FBA919"/>
+                </a:solidFill>
+                <a:latin typeface="Calibri" pitchFamily="34" charset="0"/>
+                <a:ea typeface="Calibri" pitchFamily="34" charset="-122"/>
+                <a:cs typeface="Calibri" pitchFamily="34" charset="-120"/>
+              </a:rPr>
+              <a:t>SERVICIOS</a:t>
+            </a:r>
+            <a:endParaRPr lang="en-US" sz="1000" dirty="0"/>
+          </a:p>
+        </p:txBody>
+      </p:sp>
+      <p:sp>
+        <p:nvSpPr>
+          <p:cNvPr id="14" name="Shape 11"/>
+          <p:cNvSpPr/>
+          <p:nvPr/>
+        </p:nvSpPr>
+        <p:spPr>
+          <a:xfrm>
+            <a:off x="640080" y="4041648"/>
+            <a:ext cx="1664208" cy="658368"/>
+          </a:xfrm>
+          <a:prstGeom prst="roundRect">
+            <a:avLst>
+              <a:gd name="adj" fmla="val 19444"/>
+            </a:avLst>
+          </a:prstGeom>
+          <a:solidFill>
+            <a:srgbClr val="18215C"/>
+          </a:solidFill>
+          <a:ln w="7620">
+            <a:solidFill>
+              <a:srgbClr val="FFFFFF">
+                <a:alpha val="12000"/>
+              </a:srgbClr>
+            </a:solidFill>
+            <a:prstDash val="solid"/>
+          </a:ln>
+          <a:effectLst>
+            <a:outerShdw sx="100000" sy="100000" kx="0" ky="0" algn="bl" rotWithShape="0" blurRad="177800" dist="50800" dir="5400000">
+              <a:srgbClr val="000000">
+                <a:alpha val="30000"/>
+              </a:srgbClr>
+            </a:outerShdw>
+          </a:effectLst>
+        </p:spPr>
+      </p:sp>
+      <p:sp>
+        <p:nvSpPr>
+          <p:cNvPr id="15" name="Text 12"/>
+          <p:cNvSpPr/>
+          <p:nvPr/>
+        </p:nvSpPr>
+        <p:spPr>
+          <a:xfrm>
+            <a:off x="640080" y="4041648"/>
+            <a:ext cx="1664208" cy="658368"/>
+          </a:xfrm>
+          <a:prstGeom prst="rect">
+            <a:avLst/>
+          </a:prstGeom>
+          <a:noFill/>
+          <a:ln/>
+        </p:spPr>
+        <p:txBody>
+          <a:bodyPr wrap="square" lIns="0" tIns="0" rIns="0" bIns="0" rtlCol="0" anchor="ctr"/>
+          <a:lstStyle/>
+          <a:p>
+            <a:pPr algn="ctr" indent="0" marL="0">
+              <a:buNone/>
+            </a:pPr>
+            <a:r>
+              <a:rPr lang="en-US" sz="1150" b="1" dirty="0">
+                <a:solidFill>
+                  <a:srgbClr val="FFFFFF"/>
+                </a:solidFill>
+                <a:latin typeface="Calibri" pitchFamily="34" charset="0"/>
+                <a:ea typeface="Calibri" pitchFamily="34" charset="-122"/>
+                <a:cs typeface="Calibri" pitchFamily="34" charset="-120"/>
+              </a:rPr>
+              <a:t>Identidad</a:t>
+            </a:r>
+            <a:endParaRPr lang="en-US" sz="1150" dirty="0"/>
+          </a:p>
+        </p:txBody>
+      </p:sp>
+      <p:sp>
+        <p:nvSpPr>
+          <p:cNvPr id="16" name="Shape 13"/>
+          <p:cNvSpPr/>
+          <p:nvPr/>
+        </p:nvSpPr>
+        <p:spPr>
+          <a:xfrm>
+            <a:off x="2386584" y="4041648"/>
+            <a:ext cx="1664208" cy="658368"/>
+          </a:xfrm>
+          <a:prstGeom prst="roundRect">
+            <a:avLst>
+              <a:gd name="adj" fmla="val 19444"/>
+            </a:avLst>
+          </a:prstGeom>
+          <a:solidFill>
+            <a:srgbClr val="18215C"/>
+          </a:solidFill>
+          <a:ln w="7620">
+            <a:solidFill>
+              <a:srgbClr val="FFFFFF">
+                <a:alpha val="12000"/>
+              </a:srgbClr>
+            </a:solidFill>
+            <a:prstDash val="solid"/>
+          </a:ln>
+          <a:effectLst>
+            <a:outerShdw sx="100000" sy="100000" kx="0" ky="0" algn="bl" rotWithShape="0" blurRad="177800" dist="50800" dir="5400000">
+              <a:srgbClr val="000000">
+                <a:alpha val="30000"/>
+              </a:srgbClr>
+            </a:outerShdw>
+          </a:effectLst>
+        </p:spPr>
+      </p:sp>
+      <p:sp>
+        <p:nvSpPr>
+          <p:cNvPr id="17" name="Text 14"/>
+          <p:cNvSpPr/>
+          <p:nvPr/>
+        </p:nvSpPr>
+        <p:spPr>
+          <a:xfrm>
+            <a:off x="2386584" y="4041648"/>
+            <a:ext cx="1664208" cy="658368"/>
+          </a:xfrm>
+          <a:prstGeom prst="rect">
+            <a:avLst/>
+          </a:prstGeom>
+          <a:noFill/>
+          <a:ln/>
+        </p:spPr>
+        <p:txBody>
+          <a:bodyPr wrap="square" lIns="0" tIns="0" rIns="0" bIns="0" rtlCol="0" anchor="ctr"/>
+          <a:lstStyle/>
+          <a:p>
+            <a:pPr algn="ctr" indent="0" marL="0">
+              <a:buNone/>
+            </a:pPr>
+            <a:r>
+              <a:rPr lang="en-US" sz="1150" b="1" dirty="0">
+                <a:solidFill>
+                  <a:srgbClr val="FFFFFF"/>
+                </a:solidFill>
+                <a:latin typeface="Calibri" pitchFamily="34" charset="0"/>
+                <a:ea typeface="Calibri" pitchFamily="34" charset="-122"/>
+                <a:cs typeface="Calibri" pitchFamily="34" charset="-120"/>
+              </a:rPr>
+              <a:t>Motor de beneficios</a:t>
+            </a:r>
+            <a:endParaRPr lang="en-US" sz="1150" dirty="0"/>
+          </a:p>
+        </p:txBody>
+      </p:sp>
+      <p:sp>
+        <p:nvSpPr>
+          <p:cNvPr id="18" name="Shape 15"/>
+          <p:cNvSpPr/>
+          <p:nvPr/>
+        </p:nvSpPr>
+        <p:spPr>
+          <a:xfrm>
+            <a:off x="4133088" y="4041648"/>
+            <a:ext cx="1664208" cy="658368"/>
+          </a:xfrm>
+          <a:prstGeom prst="roundRect">
+            <a:avLst>
+              <a:gd name="adj" fmla="val 19444"/>
+            </a:avLst>
+          </a:prstGeom>
+          <a:solidFill>
+            <a:srgbClr val="18215C"/>
+          </a:solidFill>
+          <a:ln w="7620">
+            <a:solidFill>
+              <a:srgbClr val="FFFFFF">
+                <a:alpha val="12000"/>
+              </a:srgbClr>
+            </a:solidFill>
+            <a:prstDash val="solid"/>
+          </a:ln>
+          <a:effectLst>
+            <a:outerShdw sx="100000" sy="100000" kx="0" ky="0" algn="bl" rotWithShape="0" blurRad="177800" dist="50800" dir="5400000">
+              <a:srgbClr val="000000">
+                <a:alpha val="30000"/>
+              </a:srgbClr>
+            </a:outerShdw>
+          </a:effectLst>
+        </p:spPr>
+      </p:sp>
+      <p:sp>
+        <p:nvSpPr>
+          <p:cNvPr id="19" name="Text 16"/>
+          <p:cNvSpPr/>
+          <p:nvPr/>
+        </p:nvSpPr>
+        <p:spPr>
+          <a:xfrm>
+            <a:off x="4133088" y="4041648"/>
+            <a:ext cx="1664208" cy="658368"/>
+          </a:xfrm>
+          <a:prstGeom prst="rect">
+            <a:avLst/>
+          </a:prstGeom>
+          <a:noFill/>
+          <a:ln/>
+        </p:spPr>
+        <p:txBody>
+          <a:bodyPr wrap="square" lIns="0" tIns="0" rIns="0" bIns="0" rtlCol="0" anchor="ctr"/>
+          <a:lstStyle/>
+          <a:p>
+            <a:pPr algn="ctr" indent="0" marL="0">
+              <a:buNone/>
+            </a:pPr>
+            <a:r>
+              <a:rPr lang="en-US" sz="1150" b="1" dirty="0">
+                <a:solidFill>
+                  <a:srgbClr val="FFFFFF"/>
+                </a:solidFill>
+                <a:latin typeface="Calibri" pitchFamily="34" charset="0"/>
+                <a:ea typeface="Calibri" pitchFamily="34" charset="-122"/>
+                <a:cs typeface="Calibri" pitchFamily="34" charset="-120"/>
+              </a:rPr>
+              <a:t>Billetera y saldos</a:t>
+            </a:r>
+            <a:endParaRPr lang="en-US" sz="1150" dirty="0"/>
+          </a:p>
+        </p:txBody>
+      </p:sp>
+      <p:sp>
+        <p:nvSpPr>
+          <p:cNvPr id="20" name="Shape 17"/>
+          <p:cNvSpPr/>
+          <p:nvPr/>
+        </p:nvSpPr>
+        <p:spPr>
+          <a:xfrm>
+            <a:off x="5879592" y="4041648"/>
+            <a:ext cx="1664208" cy="658368"/>
+          </a:xfrm>
+          <a:prstGeom prst="roundRect">
+            <a:avLst>
+              <a:gd name="adj" fmla="val 19444"/>
+            </a:avLst>
+          </a:prstGeom>
+          <a:solidFill>
+            <a:srgbClr val="18215C"/>
+          </a:solidFill>
+          <a:ln w="7620">
+            <a:solidFill>
+              <a:srgbClr val="FFFFFF">
+                <a:alpha val="12000"/>
+              </a:srgbClr>
+            </a:solidFill>
+            <a:prstDash val="solid"/>
+          </a:ln>
+          <a:effectLst>
+            <a:outerShdw sx="100000" sy="100000" kx="0" ky="0" algn="bl" rotWithShape="0" blurRad="177800" dist="50800" dir="5400000">
+              <a:srgbClr val="000000">
+                <a:alpha val="30000"/>
+              </a:srgbClr>
+            </a:outerShdw>
+          </a:effectLst>
+        </p:spPr>
+      </p:sp>
+      <p:sp>
+        <p:nvSpPr>
+          <p:cNvPr id="21" name="Text 18"/>
+          <p:cNvSpPr/>
+          <p:nvPr/>
+        </p:nvSpPr>
+        <p:spPr>
+          <a:xfrm>
+            <a:off x="5879592" y="4041648"/>
+            <a:ext cx="1664208" cy="658368"/>
+          </a:xfrm>
+          <a:prstGeom prst="rect">
+            <a:avLst/>
+          </a:prstGeom>
+          <a:noFill/>
+          <a:ln/>
+        </p:spPr>
+        <p:txBody>
+          <a:bodyPr wrap="square" lIns="0" tIns="0" rIns="0" bIns="0" rtlCol="0" anchor="ctr"/>
+          <a:lstStyle/>
+          <a:p>
+            <a:pPr algn="ctr" indent="0" marL="0">
+              <a:buNone/>
+            </a:pPr>
+            <a:r>
+              <a:rPr lang="en-US" sz="1150" b="1" dirty="0">
+                <a:solidFill>
+                  <a:srgbClr val="FFFFFF"/>
+                </a:solidFill>
+                <a:latin typeface="Calibri" pitchFamily="34" charset="0"/>
+                <a:ea typeface="Calibri" pitchFamily="34" charset="-122"/>
+                <a:cs typeface="Calibri" pitchFamily="34" charset="-120"/>
+              </a:rPr>
+              <a:t>Transacciones</a:t>
+            </a:r>
+            <a:endParaRPr lang="en-US" sz="1150" dirty="0"/>
+          </a:p>
+        </p:txBody>
+      </p:sp>
+      <p:sp>
+        <p:nvSpPr>
+          <p:cNvPr id="22" name="Text 19"/>
+          <p:cNvSpPr/>
+          <p:nvPr/>
+        </p:nvSpPr>
+        <p:spPr>
+          <a:xfrm>
+            <a:off x="640080" y="4846320"/>
+            <a:ext cx="6903720" cy="219456"/>
+          </a:xfrm>
+          <a:prstGeom prst="rect">
+            <a:avLst/>
+          </a:prstGeom>
+          <a:noFill/>
+          <a:ln/>
+        </p:spPr>
+        <p:txBody>
+          <a:bodyPr wrap="square" lIns="0" tIns="0" rIns="0" bIns="0" rtlCol="0" anchor="ctr"/>
+          <a:lstStyle/>
+          <a:p>
+            <a:pPr indent="0" marL="0">
+              <a:buNone/>
+            </a:pPr>
+            <a:r>
+              <a:rPr lang="en-US" sz="1000" b="1" spc="180" kern="0" dirty="0">
+                <a:solidFill>
+                  <a:srgbClr val="FBA919"/>
+                </a:solidFill>
+                <a:latin typeface="Calibri" pitchFamily="34" charset="0"/>
+                <a:ea typeface="Calibri" pitchFamily="34" charset="-122"/>
+                <a:cs typeface="Calibri" pitchFamily="34" charset="-120"/>
+              </a:rPr>
+              <a:t>CONECTORES A LOS SISTEMAS ACTUALES</a:t>
+            </a:r>
+            <a:endParaRPr lang="en-US" sz="1000" dirty="0"/>
+          </a:p>
+        </p:txBody>
+      </p:sp>
+      <p:sp>
+        <p:nvSpPr>
+          <p:cNvPr id="23" name="Shape 20"/>
+          <p:cNvSpPr/>
+          <p:nvPr/>
+        </p:nvSpPr>
+        <p:spPr>
+          <a:xfrm>
+            <a:off x="640080" y="5074920"/>
+            <a:ext cx="1097280" cy="475488"/>
+          </a:xfrm>
+          <a:prstGeom prst="roundRect">
+            <a:avLst>
+              <a:gd name="adj" fmla="val 19231"/>
+            </a:avLst>
+          </a:prstGeom>
+          <a:solidFill>
+            <a:srgbClr val="0E1746"/>
+          </a:solidFill>
+          <a:ln w="10160">
+            <a:solidFill>
+              <a:srgbClr val="FBA919">
+                <a:alpha val="45000"/>
+              </a:srgbClr>
+            </a:solidFill>
+            <a:prstDash val="solid"/>
+          </a:ln>
+        </p:spPr>
+      </p:sp>
+      <p:sp>
+        <p:nvSpPr>
+          <p:cNvPr id="24" name="Text 21"/>
+          <p:cNvSpPr/>
+          <p:nvPr/>
+        </p:nvSpPr>
+        <p:spPr>
+          <a:xfrm>
+            <a:off x="640080" y="5074920"/>
+            <a:ext cx="1097280" cy="475488"/>
+          </a:xfrm>
+          <a:prstGeom prst="rect">
+            <a:avLst/>
+          </a:prstGeom>
+          <a:noFill/>
+          <a:ln/>
+        </p:spPr>
+        <p:txBody>
+          <a:bodyPr wrap="square" lIns="0" tIns="0" rIns="0" bIns="0" rtlCol="0" anchor="ctr"/>
+          <a:lstStyle/>
+          <a:p>
+            <a:pPr algn="ctr" indent="0" marL="0">
+              <a:buNone/>
+            </a:pPr>
+            <a:r>
+              <a:rPr lang="en-US" sz="950" dirty="0">
+                <a:solidFill>
+                  <a:srgbClr val="A9B2DC"/>
+                </a:solidFill>
+                <a:latin typeface="Calibri" pitchFamily="34" charset="0"/>
+                <a:ea typeface="Calibri" pitchFamily="34" charset="-122"/>
+                <a:cs typeface="Calibri" pitchFamily="34" charset="-120"/>
+              </a:rPr>
+              <a:t>Bonus</a:t>
+            </a:r>
+            <a:endParaRPr lang="en-US" sz="950" dirty="0"/>
+          </a:p>
+        </p:txBody>
+      </p:sp>
+      <p:sp>
+        <p:nvSpPr>
+          <p:cNvPr id="25" name="Shape 22"/>
+          <p:cNvSpPr/>
+          <p:nvPr/>
+        </p:nvSpPr>
+        <p:spPr>
+          <a:xfrm>
+            <a:off x="1801368" y="5074920"/>
+            <a:ext cx="1097280" cy="475488"/>
+          </a:xfrm>
+          <a:prstGeom prst="roundRect">
+            <a:avLst>
+              <a:gd name="adj" fmla="val 19231"/>
+            </a:avLst>
+          </a:prstGeom>
+          <a:solidFill>
+            <a:srgbClr val="0E1746"/>
+          </a:solidFill>
+          <a:ln w="10160">
+            <a:solidFill>
+              <a:srgbClr val="FBA919">
+                <a:alpha val="45000"/>
+              </a:srgbClr>
+            </a:solidFill>
+            <a:prstDash val="solid"/>
+          </a:ln>
+        </p:spPr>
+      </p:sp>
+      <p:sp>
+        <p:nvSpPr>
+          <p:cNvPr id="26" name="Text 23"/>
+          <p:cNvSpPr/>
+          <p:nvPr/>
+        </p:nvSpPr>
+        <p:spPr>
+          <a:xfrm>
+            <a:off x="1801368" y="5074920"/>
+            <a:ext cx="1097280" cy="475488"/>
+          </a:xfrm>
+          <a:prstGeom prst="rect">
+            <a:avLst/>
+          </a:prstGeom>
+          <a:noFill/>
+          <a:ln/>
+        </p:spPr>
+        <p:txBody>
+          <a:bodyPr wrap="square" lIns="0" tIns="0" rIns="0" bIns="0" rtlCol="0" anchor="ctr"/>
+          <a:lstStyle/>
+          <a:p>
+            <a:pPr algn="ctr" indent="0" marL="0">
+              <a:buNone/>
+            </a:pPr>
+            <a:r>
+              <a:rPr lang="en-US" sz="950" dirty="0">
+                <a:solidFill>
+                  <a:srgbClr val="A9B2DC"/>
+                </a:solidFill>
+                <a:latin typeface="Calibri" pitchFamily="34" charset="0"/>
+                <a:ea typeface="Calibri" pitchFamily="34" charset="-122"/>
+                <a:cs typeface="Calibri" pitchFamily="34" charset="-120"/>
+              </a:rPr>
+              <a:t>Sellos LiSTO!</a:t>
+            </a:r>
+            <a:endParaRPr lang="en-US" sz="950" dirty="0"/>
+          </a:p>
+        </p:txBody>
+      </p:sp>
+      <p:sp>
+        <p:nvSpPr>
+          <p:cNvPr id="27" name="Shape 24"/>
+          <p:cNvSpPr/>
+          <p:nvPr/>
+        </p:nvSpPr>
+        <p:spPr>
+          <a:xfrm>
+            <a:off x="2962656" y="5074920"/>
+            <a:ext cx="1097280" cy="475488"/>
+          </a:xfrm>
+          <a:prstGeom prst="roundRect">
+            <a:avLst>
+              <a:gd name="adj" fmla="val 19231"/>
+            </a:avLst>
+          </a:prstGeom>
+          <a:solidFill>
+            <a:srgbClr val="0E1746"/>
+          </a:solidFill>
+          <a:ln w="10160">
+            <a:solidFill>
+              <a:srgbClr val="FBA919">
+                <a:alpha val="45000"/>
+              </a:srgbClr>
+            </a:solidFill>
+            <a:prstDash val="solid"/>
+          </a:ln>
+        </p:spPr>
+      </p:sp>
+      <p:sp>
+        <p:nvSpPr>
+          <p:cNvPr id="28" name="Text 25"/>
+          <p:cNvSpPr/>
+          <p:nvPr/>
+        </p:nvSpPr>
+        <p:spPr>
+          <a:xfrm>
+            <a:off x="2962656" y="5074920"/>
+            <a:ext cx="1097280" cy="475488"/>
+          </a:xfrm>
+          <a:prstGeom prst="rect">
+            <a:avLst/>
+          </a:prstGeom>
+          <a:noFill/>
+          <a:ln/>
+        </p:spPr>
+        <p:txBody>
+          <a:bodyPr wrap="square" lIns="0" tIns="0" rIns="0" bIns="0" rtlCol="0" anchor="ctr"/>
+          <a:lstStyle/>
+          <a:p>
+            <a:pPr algn="ctr" indent="0" marL="0">
+              <a:buNone/>
+            </a:pPr>
+            <a:r>
+              <a:rPr lang="en-US" sz="950" dirty="0">
+                <a:solidFill>
+                  <a:srgbClr val="A9B2DC"/>
+                </a:solidFill>
+                <a:latin typeface="Calibri" pitchFamily="34" charset="0"/>
+                <a:ea typeface="Calibri" pitchFamily="34" charset="-122"/>
+                <a:cs typeface="Calibri" pitchFamily="34" charset="-120"/>
+              </a:rPr>
+              <a:t>Convenios</a:t>
+            </a:r>
+            <a:endParaRPr lang="en-US" sz="950" dirty="0"/>
+          </a:p>
+        </p:txBody>
+      </p:sp>
+      <p:sp>
+        <p:nvSpPr>
+          <p:cNvPr id="29" name="Shape 26"/>
+          <p:cNvSpPr/>
+          <p:nvPr/>
+        </p:nvSpPr>
+        <p:spPr>
+          <a:xfrm>
+            <a:off x="4123944" y="5074920"/>
+            <a:ext cx="1097280" cy="475488"/>
+          </a:xfrm>
+          <a:prstGeom prst="roundRect">
+            <a:avLst>
+              <a:gd name="adj" fmla="val 19231"/>
+            </a:avLst>
+          </a:prstGeom>
+          <a:solidFill>
+            <a:srgbClr val="0E1746"/>
+          </a:solidFill>
+          <a:ln w="10160">
+            <a:solidFill>
+              <a:srgbClr val="FBA919">
+                <a:alpha val="45000"/>
+              </a:srgbClr>
+            </a:solidFill>
+            <a:prstDash val="solid"/>
+          </a:ln>
+        </p:spPr>
+      </p:sp>
+      <p:sp>
+        <p:nvSpPr>
+          <p:cNvPr id="30" name="Text 27"/>
+          <p:cNvSpPr/>
+          <p:nvPr/>
+        </p:nvSpPr>
+        <p:spPr>
+          <a:xfrm>
+            <a:off x="4123944" y="5074920"/>
+            <a:ext cx="1097280" cy="475488"/>
+          </a:xfrm>
+          <a:prstGeom prst="rect">
+            <a:avLst/>
+          </a:prstGeom>
+          <a:noFill/>
+          <a:ln/>
+        </p:spPr>
+        <p:txBody>
+          <a:bodyPr wrap="square" lIns="0" tIns="0" rIns="0" bIns="0" rtlCol="0" anchor="ctr"/>
+          <a:lstStyle/>
+          <a:p>
+            <a:pPr algn="ctr" indent="0" marL="0">
+              <a:buNone/>
+            </a:pPr>
+            <a:r>
+              <a:rPr lang="en-US" sz="950" dirty="0">
+                <a:solidFill>
+                  <a:srgbClr val="A9B2DC"/>
+                </a:solidFill>
+                <a:latin typeface="Calibri" pitchFamily="34" charset="0"/>
+                <a:ea typeface="Calibri" pitchFamily="34" charset="-122"/>
+                <a:cs typeface="Calibri" pitchFamily="34" charset="-120"/>
+              </a:rPr>
+              <a:t>POS estación</a:t>
+            </a:r>
+            <a:endParaRPr lang="en-US" sz="950" dirty="0"/>
+          </a:p>
+        </p:txBody>
+      </p:sp>
+      <p:sp>
+        <p:nvSpPr>
+          <p:cNvPr id="31" name="Shape 28"/>
+          <p:cNvSpPr/>
+          <p:nvPr/>
+        </p:nvSpPr>
+        <p:spPr>
+          <a:xfrm>
+            <a:off x="5285232" y="5074920"/>
+            <a:ext cx="1097280" cy="475488"/>
+          </a:xfrm>
+          <a:prstGeom prst="roundRect">
+            <a:avLst>
+              <a:gd name="adj" fmla="val 19231"/>
+            </a:avLst>
+          </a:prstGeom>
+          <a:solidFill>
+            <a:srgbClr val="0E1746"/>
+          </a:solidFill>
+          <a:ln w="10160">
+            <a:solidFill>
+              <a:srgbClr val="FBA919">
+                <a:alpha val="45000"/>
+              </a:srgbClr>
+            </a:solidFill>
+            <a:prstDash val="solid"/>
+          </a:ln>
+        </p:spPr>
+      </p:sp>
+      <p:sp>
+        <p:nvSpPr>
+          <p:cNvPr id="32" name="Text 29"/>
+          <p:cNvSpPr/>
+          <p:nvPr/>
+        </p:nvSpPr>
+        <p:spPr>
+          <a:xfrm>
+            <a:off x="5285232" y="5074920"/>
+            <a:ext cx="1097280" cy="475488"/>
+          </a:xfrm>
+          <a:prstGeom prst="rect">
+            <a:avLst/>
+          </a:prstGeom>
+          <a:noFill/>
+          <a:ln/>
+        </p:spPr>
+        <p:txBody>
+          <a:bodyPr wrap="square" lIns="0" tIns="0" rIns="0" bIns="0" rtlCol="0" anchor="ctr"/>
+          <a:lstStyle/>
+          <a:p>
+            <a:pPr algn="ctr" indent="0" marL="0">
+              <a:buNone/>
+            </a:pPr>
+            <a:r>
+              <a:rPr lang="en-US" sz="950" dirty="0">
+                <a:solidFill>
+                  <a:srgbClr val="A9B2DC"/>
+                </a:solidFill>
+                <a:latin typeface="Calibri" pitchFamily="34" charset="0"/>
+                <a:ea typeface="Calibri" pitchFamily="34" charset="-122"/>
+                <a:cs typeface="Calibri" pitchFamily="34" charset="-120"/>
+              </a:rPr>
+              <a:t>Primax Gas</a:t>
+            </a:r>
+            <a:endParaRPr lang="en-US" sz="950" dirty="0"/>
+          </a:p>
+        </p:txBody>
+      </p:sp>
+      <p:sp>
+        <p:nvSpPr>
+          <p:cNvPr id="33" name="Shape 30"/>
+          <p:cNvSpPr/>
+          <p:nvPr/>
+        </p:nvSpPr>
+        <p:spPr>
+          <a:xfrm>
+            <a:off x="6446520" y="5074920"/>
+            <a:ext cx="1097280" cy="475488"/>
+          </a:xfrm>
+          <a:prstGeom prst="roundRect">
+            <a:avLst>
+              <a:gd name="adj" fmla="val 19231"/>
+            </a:avLst>
+          </a:prstGeom>
+          <a:solidFill>
+            <a:srgbClr val="0E1746"/>
+          </a:solidFill>
+          <a:ln w="10160">
+            <a:solidFill>
+              <a:srgbClr val="FBA919">
+                <a:alpha val="45000"/>
+              </a:srgbClr>
+            </a:solidFill>
+            <a:prstDash val="solid"/>
+          </a:ln>
+        </p:spPr>
+      </p:sp>
+      <p:sp>
+        <p:nvSpPr>
+          <p:cNvPr id="34" name="Text 31"/>
+          <p:cNvSpPr/>
+          <p:nvPr/>
+        </p:nvSpPr>
+        <p:spPr>
+          <a:xfrm>
+            <a:off x="6446520" y="5074920"/>
+            <a:ext cx="1097280" cy="475488"/>
+          </a:xfrm>
+          <a:prstGeom prst="rect">
+            <a:avLst/>
+          </a:prstGeom>
+          <a:noFill/>
+          <a:ln/>
+        </p:spPr>
+        <p:txBody>
+          <a:bodyPr wrap="square" lIns="0" tIns="0" rIns="0" bIns="0" rtlCol="0" anchor="ctr"/>
+          <a:lstStyle/>
+          <a:p>
+            <a:pPr algn="ctr" indent="0" marL="0">
+              <a:buNone/>
+            </a:pPr>
+            <a:r>
+              <a:rPr lang="en-US" sz="950" dirty="0">
+                <a:solidFill>
+                  <a:srgbClr val="A9B2DC"/>
+                </a:solidFill>
+                <a:latin typeface="Calibri" pitchFamily="34" charset="0"/>
+                <a:ea typeface="Calibri" pitchFamily="34" charset="-122"/>
+                <a:cs typeface="Calibri" pitchFamily="34" charset="-120"/>
+              </a:rPr>
+              <a:t>Shell</a:t>
+            </a:r>
+            <a:endParaRPr lang="en-US" sz="950" dirty="0"/>
+          </a:p>
+        </p:txBody>
+      </p:sp>
+      <p:sp>
+        <p:nvSpPr>
+          <p:cNvPr id="35" name="Shape 32"/>
+          <p:cNvSpPr/>
+          <p:nvPr/>
+        </p:nvSpPr>
+        <p:spPr>
+          <a:xfrm>
+            <a:off x="7772400" y="2148840"/>
+            <a:ext cx="3776472" cy="3401568"/>
+          </a:xfrm>
+          <a:prstGeom prst="roundRect">
+            <a:avLst>
+              <a:gd name="adj" fmla="val 3763"/>
+            </a:avLst>
+          </a:prstGeom>
+          <a:solidFill>
+            <a:srgbClr val="18215C"/>
+          </a:solidFill>
+          <a:ln w="7620">
+            <a:solidFill>
+              <a:srgbClr val="FFFFFF">
+                <a:alpha val="12000"/>
+              </a:srgbClr>
+            </a:solidFill>
+            <a:prstDash val="solid"/>
+          </a:ln>
+          <a:effectLst>
+            <a:outerShdw sx="100000" sy="100000" kx="0" ky="0" algn="bl" rotWithShape="0" blurRad="177800" dist="50800" dir="5400000">
+              <a:srgbClr val="000000">
+                <a:alpha val="30000"/>
+              </a:srgbClr>
+            </a:outerShdw>
+          </a:effectLst>
+        </p:spPr>
+      </p:sp>
+      <p:sp>
+        <p:nvSpPr>
+          <p:cNvPr id="36" name="Text 33"/>
+          <p:cNvSpPr/>
+          <p:nvPr/>
+        </p:nvSpPr>
+        <p:spPr>
+          <a:xfrm>
+            <a:off x="8074152" y="2395728"/>
+            <a:ext cx="3200400" cy="274320"/>
+          </a:xfrm>
+          <a:prstGeom prst="rect">
+            <a:avLst/>
+          </a:prstGeom>
+          <a:noFill/>
+          <a:ln/>
+        </p:spPr>
+        <p:txBody>
+          <a:bodyPr wrap="square" lIns="0" tIns="0" rIns="0" bIns="0" rtlCol="0" anchor="ctr"/>
+          <a:lstStyle/>
+          <a:p>
+            <a:pPr indent="0" marL="0">
+              <a:buNone/>
+            </a:pPr>
+            <a:r>
+              <a:rPr lang="en-US" sz="1100" b="1" spc="180" kern="0" dirty="0">
+                <a:solidFill>
+                  <a:srgbClr val="FBA919"/>
+                </a:solidFill>
+                <a:latin typeface="Calibri" pitchFamily="34" charset="0"/>
+                <a:ea typeface="Calibri" pitchFamily="34" charset="-122"/>
+                <a:cs typeface="Calibri" pitchFamily="34" charset="-120"/>
+              </a:rPr>
+              <a:t>PRINCIPIOS TÉCNICOS</a:t>
+            </a:r>
+            <a:endParaRPr lang="en-US" sz="1100" dirty="0"/>
+          </a:p>
+        </p:txBody>
+      </p:sp>
+      <p:sp>
+        <p:nvSpPr>
+          <p:cNvPr id="37" name="Text 34"/>
+          <p:cNvSpPr/>
+          <p:nvPr/>
+        </p:nvSpPr>
+        <p:spPr>
+          <a:xfrm>
+            <a:off x="8074152" y="2788920"/>
+            <a:ext cx="3200400" cy="2606040"/>
+          </a:xfrm>
+          <a:prstGeom prst="rect">
+            <a:avLst/>
+          </a:prstGeom>
+          <a:noFill/>
+          <a:ln/>
+        </p:spPr>
+        <p:txBody>
+          <a:bodyPr wrap="square" lIns="0" tIns="0" rIns="0" bIns="0" rtlCol="0" anchor="ctr"/>
+          <a:lstStyle/>
+          <a:p>
+            <a:pPr marL="342900" indent="-342900">
+              <a:lnSpc>
+                <a:spcPts val="1500"/>
+              </a:lnSpc>
+              <a:spcAft>
+                <a:spcPts val="1100"/>
+              </a:spcAft>
+              <a:buSzPct val="100000"/>
+              <a:buChar char="•"/>
+            </a:pPr>
+            <a:r>
+              <a:rPr lang="en-US" sz="1150" dirty="0">
+                <a:solidFill>
+                  <a:srgbClr val="FFFFFF"/>
+                </a:solidFill>
+                <a:latin typeface="Calibri" pitchFamily="34" charset="0"/>
+                <a:ea typeface="Calibri" pitchFamily="34" charset="-122"/>
+                <a:cs typeface="Calibri" pitchFamily="34" charset="-120"/>
+              </a:rPr>
+              <a:t>Motor de reglas como servicio, con simulación: cambiar un beneficio no es un release de la app.</a:t>
+            </a:r>
+            <a:endParaRPr lang="en-US" sz="1150" dirty="0"/>
+          </a:p>
+          <a:p>
+            <a:pPr marL="342900" indent="-342900">
+              <a:lnSpc>
+                <a:spcPts val="1500"/>
+              </a:lnSpc>
+              <a:spcAft>
+                <a:spcPts val="1100"/>
+              </a:spcAft>
+              <a:buSzPct val="100000"/>
+              <a:buChar char="•"/>
+            </a:pPr>
+            <a:r>
+              <a:rPr lang="en-US" sz="1150" dirty="0">
+                <a:solidFill>
+                  <a:srgbClr val="FFFFFF"/>
+                </a:solidFill>
+                <a:latin typeface="Calibri" pitchFamily="34" charset="0"/>
+                <a:ea typeface="Calibri" pitchFamily="34" charset="-122"/>
+                <a:cs typeface="Calibri" pitchFamily="34" charset="-120"/>
+              </a:rPr>
+              <a:t>Idempotencia y conciliación en cada transacción — una compra impacta tres programas.</a:t>
+            </a:r>
+            <a:endParaRPr lang="en-US" sz="1150" dirty="0"/>
+          </a:p>
+          <a:p>
+            <a:pPr marL="342900" indent="-342900">
+              <a:lnSpc>
+                <a:spcPts val="1500"/>
+              </a:lnSpc>
+              <a:spcAft>
+                <a:spcPts val="1100"/>
+              </a:spcAft>
+              <a:buSzPct val="100000"/>
+              <a:buChar char="•"/>
+            </a:pPr>
+            <a:r>
+              <a:rPr lang="en-US" sz="1150" dirty="0">
+                <a:solidFill>
+                  <a:srgbClr val="FFFFFF"/>
+                </a:solidFill>
+                <a:latin typeface="Calibri" pitchFamily="34" charset="0"/>
+                <a:ea typeface="Calibri" pitchFamily="34" charset="-122"/>
+                <a:cs typeface="Calibri" pitchFamily="34" charset="-120"/>
+              </a:rPr>
+              <a:t>Degradación elegante: si un conector se cae, la app sigue mostrando el resto.</a:t>
+            </a:r>
+            <a:endParaRPr lang="en-US" sz="1150" dirty="0"/>
+          </a:p>
+          <a:p>
+            <a:pPr marL="342900" indent="-342900">
+              <a:lnSpc>
+                <a:spcPts val="1500"/>
+              </a:lnSpc>
+              <a:spcAft>
+                <a:spcPts val="1100"/>
+              </a:spcAft>
+              <a:buSzPct val="100000"/>
+              <a:buChar char="•"/>
+            </a:pPr>
+            <a:r>
+              <a:rPr lang="en-US" sz="1150" dirty="0">
+                <a:solidFill>
+                  <a:srgbClr val="FFFFFF"/>
+                </a:solidFill>
+                <a:latin typeface="Calibri" pitchFamily="34" charset="0"/>
+                <a:ea typeface="Calibri" pitchFamily="34" charset="-122"/>
+                <a:cs typeface="Calibri" pitchFamily="34" charset="-120"/>
+              </a:rPr>
+              <a:t>Consentimiento y datos personales por diseño (Ley 29733).</a:t>
+            </a:r>
+            <a:endParaRPr lang="en-US" sz="1150" dirty="0"/>
+          </a:p>
+        </p:txBody>
+      </p:sp>
+      <p:sp>
+        <p:nvSpPr>
+          <p:cNvPr id="38" name="Text 35"/>
+          <p:cNvSpPr/>
+          <p:nvPr/>
+        </p:nvSpPr>
+        <p:spPr>
+          <a:xfrm>
+            <a:off x="640080" y="6153912"/>
+            <a:ext cx="10911535" cy="411480"/>
+          </a:xfrm>
+          <a:prstGeom prst="rect">
+            <a:avLst/>
+          </a:prstGeom>
+          <a:noFill/>
+          <a:ln/>
+        </p:spPr>
+        <p:txBody>
+          <a:bodyPr wrap="square" lIns="0" tIns="0" rIns="0" bIns="0" rtlCol="0" anchor="ctr"/>
+          <a:lstStyle/>
+          <a:p>
+            <a:pPr indent="0" marL="0">
+              <a:buNone/>
+            </a:pPr>
+            <a:r>
+              <a:rPr lang="en-US" sz="1200" i="1" dirty="0">
+                <a:solidFill>
+                  <a:srgbClr val="7F8AC0"/>
+                </a:solidFill>
+                <a:latin typeface="Calibri" pitchFamily="34" charset="0"/>
+                <a:ea typeface="Calibri" pitchFamily="34" charset="-122"/>
+                <a:cs typeface="Calibri" pitchFamily="34" charset="-120"/>
+              </a:rPr>
+              <a:t>La demo ya tiene esta forma: el motor de beneficios es una función aislada y los conectores de hoy son datos mock.</a:t>
+            </a:r>
+            <a:endParaRPr lang="en-US" sz="1200" dirty="0"/>
+          </a:p>
+        </p:txBody>
+      </p:sp>
+    </p:spTree>
+  </p:cSld>
+  <p:clrMapOvr>
+    <a:masterClrMapping/>
+  </p:clrMapOvr>
+</p:sld>
+</file>
+
 <file path=ppt/theme/theme1.xml><?xml version="1.0" encoding="utf-8"?>
 <a:theme xmlns:a="http://schemas.openxmlformats.org/drawingml/2006/main" name="Office Theme">
   <a:themeElements>

</xml_diff>